<commit_message>
020 coupler casi terminado
</commit_message>
<xml_diff>
--- a/LabBook_020.pptx
+++ b/LabBook_020.pptx
@@ -5,10 +5,10 @@
     <p:sldMasterId id="2147483648" r:id="rId1"/>
   </p:sldMasterIdLst>
   <p:notesMasterIdLst>
-    <p:notesMasterId r:id="rId13"/>
+    <p:notesMasterId r:id="rId16"/>
   </p:notesMasterIdLst>
   <p:handoutMasterIdLst>
-    <p:handoutMasterId r:id="rId14"/>
+    <p:handoutMasterId r:id="rId17"/>
   </p:handoutMasterIdLst>
   <p:sldIdLst>
     <p:sldId id="256" r:id="rId2"/>
@@ -21,7 +21,10 @@
     <p:sldId id="298" r:id="rId9"/>
     <p:sldId id="293" r:id="rId10"/>
     <p:sldId id="299" r:id="rId11"/>
-    <p:sldId id="288" r:id="rId12"/>
+    <p:sldId id="300" r:id="rId12"/>
+    <p:sldId id="302" r:id="rId13"/>
+    <p:sldId id="303" r:id="rId14"/>
+    <p:sldId id="288" r:id="rId15"/>
   </p:sldIdLst>
   <p:sldSz cx="12192000" cy="6858000"/>
   <p:notesSz cx="12192000" cy="6858000"/>
@@ -831,6 +834,222 @@
 </p:notes>
 </file>
 
+<file path=ppt/notesSlides/notesSlide10.xml><?xml version="1.0" encoding="utf-8"?>
+<p:notes xmlns:a="http://schemas.openxmlformats.org/drawingml/2006/main" xmlns:r="http://schemas.openxmlformats.org/officeDocument/2006/relationships" xmlns:p="http://schemas.openxmlformats.org/presentationml/2006/main">
+  <p:cSld>
+    <p:spTree>
+      <p:nvGrpSpPr>
+        <p:cNvPr id="1" name="">
+          <a:extLst>
+            <a:ext uri="{FF2B5EF4-FFF2-40B4-BE49-F238E27FC236}">
+              <a16:creationId xmlns:a16="http://schemas.microsoft.com/office/drawing/2014/main" id="{17C76B16-B1E0-9FE2-7BFD-FF1F3BBC9929}"/>
+            </a:ext>
+          </a:extLst>
+        </p:cNvPr>
+        <p:cNvGrpSpPr/>
+        <p:nvPr/>
+      </p:nvGrpSpPr>
+      <p:grpSpPr>
+        <a:xfrm>
+          <a:off x="0" y="0"/>
+          <a:ext cx="0" cy="0"/>
+          <a:chOff x="0" y="0"/>
+          <a:chExt cx="0" cy="0"/>
+        </a:xfrm>
+      </p:grpSpPr>
+      <p:sp>
+        <p:nvSpPr>
+          <p:cNvPr id="2" name="Marcador de imagen de diapositiva 1">
+            <a:extLst>
+              <a:ext uri="{FF2B5EF4-FFF2-40B4-BE49-F238E27FC236}">
+                <a16:creationId xmlns:a16="http://schemas.microsoft.com/office/drawing/2014/main" id="{630152F8-67AC-887A-BB89-47340F619BFA}"/>
+              </a:ext>
+            </a:extLst>
+          </p:cNvPr>
+          <p:cNvSpPr>
+            <a:spLocks noGrp="1" noRot="1" noChangeAspect="1"/>
+          </p:cNvSpPr>
+          <p:nvPr>
+            <p:ph type="sldImg"/>
+          </p:nvPr>
+        </p:nvSpPr>
+        <p:spPr/>
+      </p:sp>
+      <p:sp>
+        <p:nvSpPr>
+          <p:cNvPr id="3" name="Marcador de notas 2">
+            <a:extLst>
+              <a:ext uri="{FF2B5EF4-FFF2-40B4-BE49-F238E27FC236}">
+                <a16:creationId xmlns:a16="http://schemas.microsoft.com/office/drawing/2014/main" id="{9D64BD0A-9A18-9C45-98D6-4A59DF83B687}"/>
+              </a:ext>
+            </a:extLst>
+          </p:cNvPr>
+          <p:cNvSpPr>
+            <a:spLocks noGrp="1"/>
+          </p:cNvSpPr>
+          <p:nvPr>
+            <p:ph type="body" idx="1"/>
+          </p:nvPr>
+        </p:nvSpPr>
+        <p:spPr/>
+        <p:txBody>
+          <a:bodyPr/>
+          <a:lstStyle/>
+          <a:p>
+            <a:endParaRPr lang="es-ES" dirty="0"/>
+          </a:p>
+        </p:txBody>
+      </p:sp>
+      <p:sp>
+        <p:nvSpPr>
+          <p:cNvPr id="4" name="Marcador de número de diapositiva 3">
+            <a:extLst>
+              <a:ext uri="{FF2B5EF4-FFF2-40B4-BE49-F238E27FC236}">
+                <a16:creationId xmlns:a16="http://schemas.microsoft.com/office/drawing/2014/main" id="{5144E3F2-2233-78E6-41D4-39E348396C75}"/>
+              </a:ext>
+            </a:extLst>
+          </p:cNvPr>
+          <p:cNvSpPr>
+            <a:spLocks noGrp="1"/>
+          </p:cNvSpPr>
+          <p:nvPr>
+            <p:ph type="sldNum" sz="quarter" idx="5"/>
+          </p:nvPr>
+        </p:nvSpPr>
+        <p:spPr/>
+        <p:txBody>
+          <a:bodyPr/>
+          <a:lstStyle/>
+          <a:p>
+            <a:fld id="{676223B9-C868-4436-87D9-1A3152E1157A}" type="slidenum">
+              <a:rPr lang="es-ES" smtClean="0"/>
+              <a:t>12</a:t>
+            </a:fld>
+            <a:endParaRPr lang="es-ES"/>
+          </a:p>
+        </p:txBody>
+      </p:sp>
+    </p:spTree>
+    <p:extLst>
+      <p:ext uri="{BB962C8B-B14F-4D97-AF65-F5344CB8AC3E}">
+        <p14:creationId xmlns:p14="http://schemas.microsoft.com/office/powerpoint/2010/main" val="276466349"/>
+      </p:ext>
+    </p:extLst>
+  </p:cSld>
+  <p:clrMapOvr>
+    <a:masterClrMapping/>
+  </p:clrMapOvr>
+</p:notes>
+</file>
+
+<file path=ppt/notesSlides/notesSlide11.xml><?xml version="1.0" encoding="utf-8"?>
+<p:notes xmlns:a="http://schemas.openxmlformats.org/drawingml/2006/main" xmlns:r="http://schemas.openxmlformats.org/officeDocument/2006/relationships" xmlns:p="http://schemas.openxmlformats.org/presentationml/2006/main">
+  <p:cSld>
+    <p:spTree>
+      <p:nvGrpSpPr>
+        <p:cNvPr id="1" name="">
+          <a:extLst>
+            <a:ext uri="{FF2B5EF4-FFF2-40B4-BE49-F238E27FC236}">
+              <a16:creationId xmlns:a16="http://schemas.microsoft.com/office/drawing/2014/main" id="{76B2B70C-15DA-54D8-A19D-7FBD95EDA433}"/>
+            </a:ext>
+          </a:extLst>
+        </p:cNvPr>
+        <p:cNvGrpSpPr/>
+        <p:nvPr/>
+      </p:nvGrpSpPr>
+      <p:grpSpPr>
+        <a:xfrm>
+          <a:off x="0" y="0"/>
+          <a:ext cx="0" cy="0"/>
+          <a:chOff x="0" y="0"/>
+          <a:chExt cx="0" cy="0"/>
+        </a:xfrm>
+      </p:grpSpPr>
+      <p:sp>
+        <p:nvSpPr>
+          <p:cNvPr id="2" name="Marcador de imagen de diapositiva 1">
+            <a:extLst>
+              <a:ext uri="{FF2B5EF4-FFF2-40B4-BE49-F238E27FC236}">
+                <a16:creationId xmlns:a16="http://schemas.microsoft.com/office/drawing/2014/main" id="{F75FB432-43F1-9B5B-9D73-EED4084F018B}"/>
+              </a:ext>
+            </a:extLst>
+          </p:cNvPr>
+          <p:cNvSpPr>
+            <a:spLocks noGrp="1" noRot="1" noChangeAspect="1"/>
+          </p:cNvSpPr>
+          <p:nvPr>
+            <p:ph type="sldImg"/>
+          </p:nvPr>
+        </p:nvSpPr>
+        <p:spPr/>
+      </p:sp>
+      <p:sp>
+        <p:nvSpPr>
+          <p:cNvPr id="3" name="Marcador de notas 2">
+            <a:extLst>
+              <a:ext uri="{FF2B5EF4-FFF2-40B4-BE49-F238E27FC236}">
+                <a16:creationId xmlns:a16="http://schemas.microsoft.com/office/drawing/2014/main" id="{C42CC78C-7722-FC5A-5256-FFF6F2B96793}"/>
+              </a:ext>
+            </a:extLst>
+          </p:cNvPr>
+          <p:cNvSpPr>
+            <a:spLocks noGrp="1"/>
+          </p:cNvSpPr>
+          <p:nvPr>
+            <p:ph type="body" idx="1"/>
+          </p:nvPr>
+        </p:nvSpPr>
+        <p:spPr/>
+        <p:txBody>
+          <a:bodyPr/>
+          <a:lstStyle/>
+          <a:p>
+            <a:endParaRPr lang="es-ES" dirty="0"/>
+          </a:p>
+        </p:txBody>
+      </p:sp>
+      <p:sp>
+        <p:nvSpPr>
+          <p:cNvPr id="4" name="Marcador de número de diapositiva 3">
+            <a:extLst>
+              <a:ext uri="{FF2B5EF4-FFF2-40B4-BE49-F238E27FC236}">
+                <a16:creationId xmlns:a16="http://schemas.microsoft.com/office/drawing/2014/main" id="{156FB5F5-9B9E-9AAB-F942-2BB481D9FBDB}"/>
+              </a:ext>
+            </a:extLst>
+          </p:cNvPr>
+          <p:cNvSpPr>
+            <a:spLocks noGrp="1"/>
+          </p:cNvSpPr>
+          <p:nvPr>
+            <p:ph type="sldNum" sz="quarter" idx="5"/>
+          </p:nvPr>
+        </p:nvSpPr>
+        <p:spPr/>
+        <p:txBody>
+          <a:bodyPr/>
+          <a:lstStyle/>
+          <a:p>
+            <a:fld id="{676223B9-C868-4436-87D9-1A3152E1157A}" type="slidenum">
+              <a:rPr lang="es-ES" smtClean="0"/>
+              <a:t>13</a:t>
+            </a:fld>
+            <a:endParaRPr lang="es-ES"/>
+          </a:p>
+        </p:txBody>
+      </p:sp>
+    </p:spTree>
+    <p:extLst>
+      <p:ext uri="{BB962C8B-B14F-4D97-AF65-F5344CB8AC3E}">
+        <p14:creationId xmlns:p14="http://schemas.microsoft.com/office/powerpoint/2010/main" val="2605743071"/>
+      </p:ext>
+    </p:extLst>
+  </p:cSld>
+  <p:clrMapOvr>
+    <a:masterClrMapping/>
+  </p:clrMapOvr>
+</p:notes>
+</file>
+
 <file path=ppt/notesSlides/notesSlide2.xml><?xml version="1.0" encoding="utf-8"?>
 <p:notes xmlns:a="http://schemas.openxmlformats.org/drawingml/2006/main" xmlns:r="http://schemas.openxmlformats.org/officeDocument/2006/relationships" xmlns:p="http://schemas.openxmlformats.org/presentationml/2006/main">
   <p:cSld>
@@ -1578,6 +1797,114 @@
     <p:extLst>
       <p:ext uri="{BB962C8B-B14F-4D97-AF65-F5344CB8AC3E}">
         <p14:creationId xmlns:p14="http://schemas.microsoft.com/office/powerpoint/2010/main" val="2108796426"/>
+      </p:ext>
+    </p:extLst>
+  </p:cSld>
+  <p:clrMapOvr>
+    <a:masterClrMapping/>
+  </p:clrMapOvr>
+</p:notes>
+</file>
+
+<file path=ppt/notesSlides/notesSlide9.xml><?xml version="1.0" encoding="utf-8"?>
+<p:notes xmlns:a="http://schemas.openxmlformats.org/drawingml/2006/main" xmlns:r="http://schemas.openxmlformats.org/officeDocument/2006/relationships" xmlns:p="http://schemas.openxmlformats.org/presentationml/2006/main">
+  <p:cSld>
+    <p:spTree>
+      <p:nvGrpSpPr>
+        <p:cNvPr id="1" name="">
+          <a:extLst>
+            <a:ext uri="{FF2B5EF4-FFF2-40B4-BE49-F238E27FC236}">
+              <a16:creationId xmlns:a16="http://schemas.microsoft.com/office/drawing/2014/main" id="{C42B2B88-AFBE-F533-6FA5-06F0AFF52F0A}"/>
+            </a:ext>
+          </a:extLst>
+        </p:cNvPr>
+        <p:cNvGrpSpPr/>
+        <p:nvPr/>
+      </p:nvGrpSpPr>
+      <p:grpSpPr>
+        <a:xfrm>
+          <a:off x="0" y="0"/>
+          <a:ext cx="0" cy="0"/>
+          <a:chOff x="0" y="0"/>
+          <a:chExt cx="0" cy="0"/>
+        </a:xfrm>
+      </p:grpSpPr>
+      <p:sp>
+        <p:nvSpPr>
+          <p:cNvPr id="2" name="Marcador de imagen de diapositiva 1">
+            <a:extLst>
+              <a:ext uri="{FF2B5EF4-FFF2-40B4-BE49-F238E27FC236}">
+                <a16:creationId xmlns:a16="http://schemas.microsoft.com/office/drawing/2014/main" id="{8DF84A49-E0B8-ADB4-F35F-1236210B07EC}"/>
+              </a:ext>
+            </a:extLst>
+          </p:cNvPr>
+          <p:cNvSpPr>
+            <a:spLocks noGrp="1" noRot="1" noChangeAspect="1"/>
+          </p:cNvSpPr>
+          <p:nvPr>
+            <p:ph type="sldImg"/>
+          </p:nvPr>
+        </p:nvSpPr>
+        <p:spPr/>
+      </p:sp>
+      <p:sp>
+        <p:nvSpPr>
+          <p:cNvPr id="3" name="Marcador de notas 2">
+            <a:extLst>
+              <a:ext uri="{FF2B5EF4-FFF2-40B4-BE49-F238E27FC236}">
+                <a16:creationId xmlns:a16="http://schemas.microsoft.com/office/drawing/2014/main" id="{90CAC1C8-4561-6350-9B3D-50FE02FEFB3A}"/>
+              </a:ext>
+            </a:extLst>
+          </p:cNvPr>
+          <p:cNvSpPr>
+            <a:spLocks noGrp="1"/>
+          </p:cNvSpPr>
+          <p:nvPr>
+            <p:ph type="body" idx="1"/>
+          </p:nvPr>
+        </p:nvSpPr>
+        <p:spPr/>
+        <p:txBody>
+          <a:bodyPr/>
+          <a:lstStyle/>
+          <a:p>
+            <a:endParaRPr lang="es-ES" dirty="0"/>
+          </a:p>
+        </p:txBody>
+      </p:sp>
+      <p:sp>
+        <p:nvSpPr>
+          <p:cNvPr id="4" name="Marcador de número de diapositiva 3">
+            <a:extLst>
+              <a:ext uri="{FF2B5EF4-FFF2-40B4-BE49-F238E27FC236}">
+                <a16:creationId xmlns:a16="http://schemas.microsoft.com/office/drawing/2014/main" id="{CCE3D82E-CC69-30B8-C6F4-1692822276BB}"/>
+              </a:ext>
+            </a:extLst>
+          </p:cNvPr>
+          <p:cNvSpPr>
+            <a:spLocks noGrp="1"/>
+          </p:cNvSpPr>
+          <p:nvPr>
+            <p:ph type="sldNum" sz="quarter" idx="5"/>
+          </p:nvPr>
+        </p:nvSpPr>
+        <p:spPr/>
+        <p:txBody>
+          <a:bodyPr/>
+          <a:lstStyle/>
+          <a:p>
+            <a:fld id="{676223B9-C868-4436-87D9-1A3152E1157A}" type="slidenum">
+              <a:rPr lang="es-ES" smtClean="0"/>
+              <a:t>11</a:t>
+            </a:fld>
+            <a:endParaRPr lang="es-ES"/>
+          </a:p>
+        </p:txBody>
+      </p:sp>
+    </p:spTree>
+    <p:extLst>
+      <p:ext uri="{BB962C8B-B14F-4D97-AF65-F5344CB8AC3E}">
+        <p14:creationId xmlns:p14="http://schemas.microsoft.com/office/powerpoint/2010/main" val="50144766"/>
       </p:ext>
     </p:extLst>
   </p:cSld>
@@ -3471,8 +3798,8 @@
         </p:nvSpPr>
         <p:spPr>
           <a:xfrm>
-            <a:off x="609441" y="4860334"/>
-            <a:ext cx="11199971" cy="1200329"/>
+            <a:off x="608012" y="4903378"/>
+            <a:ext cx="11199971" cy="1754326"/>
           </a:xfrm>
           <a:prstGeom prst="rect">
             <a:avLst/>
@@ -3500,33 +3827,638 @@
                 <a:latin typeface="Arial" panose="020B0604020202020204" pitchFamily="34" charset="0"/>
                 <a:cs typeface="Arial" panose="020B0604020202020204" pitchFamily="34" charset="0"/>
               </a:rPr>
-              <a:t>Document all your results (neff, plot fields </a:t>
-            </a:r>
-            <a:r>
-              <a:rPr lang="en-US" sz="1200">
-                <a:latin typeface="Arial" panose="020B0604020202020204" pitchFamily="34" charset="0"/>
-                <a:cs typeface="Arial" panose="020B0604020202020204" pitchFamily="34" charset="0"/>
-              </a:rPr>
-              <a:t>of different modes, </a:t>
-            </a:r>
-            <a:r>
-              <a:rPr lang="en-US" sz="1200" dirty="0">
-                <a:latin typeface="Arial" panose="020B0604020202020204" pitchFamily="34" charset="0"/>
-                <a:cs typeface="Arial" panose="020B0604020202020204" pitchFamily="34" charset="0"/>
-              </a:rPr>
-              <a:t>comparison between </a:t>
-            </a:r>
-            <a:r>
-              <a:rPr lang="en-US" sz="1200">
-                <a:latin typeface="Arial" panose="020B0604020202020204" pitchFamily="34" charset="0"/>
-                <a:cs typeface="Arial" panose="020B0604020202020204" pitchFamily="34" charset="0"/>
-              </a:rPr>
-              <a:t>different polarizations…)</a:t>
-            </a:r>
-            <a:endParaRPr lang="en-US" sz="1200" dirty="0">
-              <a:latin typeface="Arial" panose="020B0604020202020204" pitchFamily="34" charset="0"/>
-              <a:cs typeface="Arial" panose="020B0604020202020204" pitchFamily="34" charset="0"/>
-            </a:endParaRPr>
+              <a:t>Los MMI se </a:t>
+            </a:r>
+            <a:r>
+              <a:rPr lang="en-US" sz="1200" dirty="0" err="1">
+                <a:latin typeface="Arial" panose="020B0604020202020204" pitchFamily="34" charset="0"/>
+                <a:cs typeface="Arial" panose="020B0604020202020204" pitchFamily="34" charset="0"/>
+              </a:rPr>
+              <a:t>caracterizan</a:t>
+            </a:r>
+            <a:r>
+              <a:rPr lang="en-US" sz="1200" dirty="0">
+                <a:latin typeface="Arial" panose="020B0604020202020204" pitchFamily="34" charset="0"/>
+                <a:cs typeface="Arial" panose="020B0604020202020204" pitchFamily="34" charset="0"/>
+              </a:rPr>
+              <a:t> </a:t>
+            </a:r>
+            <a:r>
+              <a:rPr lang="en-US" sz="1200" dirty="0" err="1">
+                <a:latin typeface="Arial" panose="020B0604020202020204" pitchFamily="34" charset="0"/>
+                <a:cs typeface="Arial" panose="020B0604020202020204" pitchFamily="34" charset="0"/>
+              </a:rPr>
+              <a:t>por</a:t>
+            </a:r>
+            <a:r>
+              <a:rPr lang="en-US" sz="1200" dirty="0">
+                <a:latin typeface="Arial" panose="020B0604020202020204" pitchFamily="34" charset="0"/>
+                <a:cs typeface="Arial" panose="020B0604020202020204" pitchFamily="34" charset="0"/>
+              </a:rPr>
+              <a:t> la replica de </a:t>
+            </a:r>
+            <a:r>
+              <a:rPr lang="en-US" sz="1200" dirty="0" err="1">
+                <a:latin typeface="Arial" panose="020B0604020202020204" pitchFamily="34" charset="0"/>
+                <a:cs typeface="Arial" panose="020B0604020202020204" pitchFamily="34" charset="0"/>
+              </a:rPr>
+              <a:t>autoimágenes</a:t>
+            </a:r>
+            <a:r>
+              <a:rPr lang="en-US" sz="1200" dirty="0">
+                <a:latin typeface="Arial" panose="020B0604020202020204" pitchFamily="34" charset="0"/>
+                <a:cs typeface="Arial" panose="020B0604020202020204" pitchFamily="34" charset="0"/>
+              </a:rPr>
+              <a:t> </a:t>
+            </a:r>
+            <a:r>
+              <a:rPr lang="en-US" sz="1200" dirty="0" err="1">
+                <a:latin typeface="Arial" panose="020B0604020202020204" pitchFamily="34" charset="0"/>
+                <a:cs typeface="Arial" panose="020B0604020202020204" pitchFamily="34" charset="0"/>
+              </a:rPr>
+              <a:t>por</a:t>
+            </a:r>
+            <a:r>
+              <a:rPr lang="en-US" sz="1200" dirty="0">
+                <a:latin typeface="Arial" panose="020B0604020202020204" pitchFamily="34" charset="0"/>
+                <a:cs typeface="Arial" panose="020B0604020202020204" pitchFamily="34" charset="0"/>
+              </a:rPr>
+              <a:t> medio de la </a:t>
+            </a:r>
+            <a:r>
+              <a:rPr lang="en-US" sz="1200" dirty="0" err="1">
+                <a:latin typeface="Arial" panose="020B0604020202020204" pitchFamily="34" charset="0"/>
+                <a:cs typeface="Arial" panose="020B0604020202020204" pitchFamily="34" charset="0"/>
+              </a:rPr>
+              <a:t>interferencia</a:t>
+            </a:r>
+            <a:r>
+              <a:rPr lang="en-US" sz="1200" dirty="0">
+                <a:latin typeface="Arial" panose="020B0604020202020204" pitchFamily="34" charset="0"/>
+                <a:cs typeface="Arial" panose="020B0604020202020204" pitchFamily="34" charset="0"/>
+              </a:rPr>
+              <a:t> entre </a:t>
+            </a:r>
+            <a:r>
+              <a:rPr lang="en-US" sz="1200" dirty="0" err="1">
+                <a:latin typeface="Arial" panose="020B0604020202020204" pitchFamily="34" charset="0"/>
+                <a:cs typeface="Arial" panose="020B0604020202020204" pitchFamily="34" charset="0"/>
+              </a:rPr>
+              <a:t>los</a:t>
+            </a:r>
+            <a:r>
+              <a:rPr lang="en-US" sz="1200" dirty="0">
+                <a:latin typeface="Arial" panose="020B0604020202020204" pitchFamily="34" charset="0"/>
+                <a:cs typeface="Arial" panose="020B0604020202020204" pitchFamily="34" charset="0"/>
+              </a:rPr>
+              <a:t> </a:t>
+            </a:r>
+            <a:r>
+              <a:rPr lang="en-US" sz="1200" dirty="0" err="1">
+                <a:latin typeface="Arial" panose="020B0604020202020204" pitchFamily="34" charset="0"/>
+                <a:cs typeface="Arial" panose="020B0604020202020204" pitchFamily="34" charset="0"/>
+              </a:rPr>
+              <a:t>modos</a:t>
+            </a:r>
+            <a:r>
+              <a:rPr lang="en-US" sz="1200" dirty="0">
+                <a:latin typeface="Arial" panose="020B0604020202020204" pitchFamily="34" charset="0"/>
+                <a:cs typeface="Arial" panose="020B0604020202020204" pitchFamily="34" charset="0"/>
+              </a:rPr>
+              <a:t>. Al ser de gran </a:t>
+            </a:r>
+            <a:r>
+              <a:rPr lang="en-US" sz="1200" dirty="0" err="1">
+                <a:latin typeface="Arial" panose="020B0604020202020204" pitchFamily="34" charset="0"/>
+                <a:cs typeface="Arial" panose="020B0604020202020204" pitchFamily="34" charset="0"/>
+              </a:rPr>
+              <a:t>tamaño</a:t>
+            </a:r>
+            <a:r>
+              <a:rPr lang="en-US" sz="1200" dirty="0">
+                <a:latin typeface="Arial" panose="020B0604020202020204" pitchFamily="34" charset="0"/>
+                <a:cs typeface="Arial" panose="020B0604020202020204" pitchFamily="34" charset="0"/>
+              </a:rPr>
+              <a:t> se </a:t>
+            </a:r>
+            <a:r>
+              <a:rPr lang="en-US" sz="1200" dirty="0" err="1">
+                <a:latin typeface="Arial" panose="020B0604020202020204" pitchFamily="34" charset="0"/>
+                <a:cs typeface="Arial" panose="020B0604020202020204" pitchFamily="34" charset="0"/>
+              </a:rPr>
+              <a:t>propagan</a:t>
+            </a:r>
+            <a:r>
+              <a:rPr lang="en-US" sz="1200" dirty="0">
+                <a:latin typeface="Arial" panose="020B0604020202020204" pitchFamily="34" charset="0"/>
+                <a:cs typeface="Arial" panose="020B0604020202020204" pitchFamily="34" charset="0"/>
+              </a:rPr>
+              <a:t> </a:t>
+            </a:r>
+            <a:r>
+              <a:rPr lang="en-US" sz="1200" dirty="0" err="1">
+                <a:latin typeface="Arial" panose="020B0604020202020204" pitchFamily="34" charset="0"/>
+                <a:cs typeface="Arial" panose="020B0604020202020204" pitchFamily="34" charset="0"/>
+              </a:rPr>
+              <a:t>una</a:t>
+            </a:r>
+            <a:r>
+              <a:rPr lang="en-US" sz="1200" dirty="0">
+                <a:latin typeface="Arial" panose="020B0604020202020204" pitchFamily="34" charset="0"/>
+                <a:cs typeface="Arial" panose="020B0604020202020204" pitchFamily="34" charset="0"/>
+              </a:rPr>
+              <a:t> gran </a:t>
+            </a:r>
+            <a:r>
+              <a:rPr lang="en-US" sz="1200" dirty="0" err="1">
+                <a:latin typeface="Arial" panose="020B0604020202020204" pitchFamily="34" charset="0"/>
+                <a:cs typeface="Arial" panose="020B0604020202020204" pitchFamily="34" charset="0"/>
+              </a:rPr>
+              <a:t>cantidad</a:t>
+            </a:r>
+            <a:r>
+              <a:rPr lang="en-US" sz="1200" dirty="0">
+                <a:latin typeface="Arial" panose="020B0604020202020204" pitchFamily="34" charset="0"/>
+                <a:cs typeface="Arial" panose="020B0604020202020204" pitchFamily="34" charset="0"/>
+              </a:rPr>
+              <a:t> de </a:t>
+            </a:r>
+            <a:r>
+              <a:rPr lang="en-US" sz="1200" dirty="0" err="1">
+                <a:latin typeface="Arial" panose="020B0604020202020204" pitchFamily="34" charset="0"/>
+                <a:cs typeface="Arial" panose="020B0604020202020204" pitchFamily="34" charset="0"/>
+              </a:rPr>
+              <a:t>modos</a:t>
+            </a:r>
+            <a:r>
+              <a:rPr lang="en-US" sz="1200" dirty="0">
+                <a:latin typeface="Arial" panose="020B0604020202020204" pitchFamily="34" charset="0"/>
+                <a:cs typeface="Arial" panose="020B0604020202020204" pitchFamily="34" charset="0"/>
+              </a:rPr>
+              <a:t>. Las </a:t>
+            </a:r>
+            <a:r>
+              <a:rPr lang="en-US" sz="1200" dirty="0" err="1">
+                <a:latin typeface="Arial" panose="020B0604020202020204" pitchFamily="34" charset="0"/>
+                <a:cs typeface="Arial" panose="020B0604020202020204" pitchFamily="34" charset="0"/>
+              </a:rPr>
+              <a:t>imágenes</a:t>
+            </a:r>
+            <a:r>
+              <a:rPr lang="en-US" sz="1200" dirty="0">
+                <a:latin typeface="Arial" panose="020B0604020202020204" pitchFamily="34" charset="0"/>
+                <a:cs typeface="Arial" panose="020B0604020202020204" pitchFamily="34" charset="0"/>
+              </a:rPr>
+              <a:t> </a:t>
+            </a:r>
+            <a:r>
+              <a:rPr lang="en-US" sz="1200" dirty="0" err="1">
+                <a:latin typeface="Arial" panose="020B0604020202020204" pitchFamily="34" charset="0"/>
+                <a:cs typeface="Arial" panose="020B0604020202020204" pitchFamily="34" charset="0"/>
+              </a:rPr>
+              <a:t>correspondientes</a:t>
+            </a:r>
+            <a:r>
+              <a:rPr lang="en-US" sz="1200" dirty="0">
+                <a:latin typeface="Arial" panose="020B0604020202020204" pitchFamily="34" charset="0"/>
+                <a:cs typeface="Arial" panose="020B0604020202020204" pitchFamily="34" charset="0"/>
+              </a:rPr>
+              <a:t> a </a:t>
+            </a:r>
+            <a:r>
+              <a:rPr lang="en-US" sz="1200" dirty="0" err="1">
+                <a:latin typeface="Arial" panose="020B0604020202020204" pitchFamily="34" charset="0"/>
+                <a:cs typeface="Arial" panose="020B0604020202020204" pitchFamily="34" charset="0"/>
+              </a:rPr>
+              <a:t>modos</a:t>
+            </a:r>
+            <a:r>
+              <a:rPr lang="en-US" sz="1200" dirty="0">
+                <a:latin typeface="Arial" panose="020B0604020202020204" pitchFamily="34" charset="0"/>
+                <a:cs typeface="Arial" panose="020B0604020202020204" pitchFamily="34" charset="0"/>
+              </a:rPr>
+              <a:t> TE, </a:t>
+            </a:r>
+            <a:r>
+              <a:rPr lang="en-US" sz="1200" dirty="0" err="1">
+                <a:latin typeface="Arial" panose="020B0604020202020204" pitchFamily="34" charset="0"/>
+                <a:cs typeface="Arial" panose="020B0604020202020204" pitchFamily="34" charset="0"/>
+              </a:rPr>
+              <a:t>correspondientes</a:t>
+            </a:r>
+            <a:r>
+              <a:rPr lang="en-US" sz="1200" dirty="0">
+                <a:latin typeface="Arial" panose="020B0604020202020204" pitchFamily="34" charset="0"/>
+                <a:cs typeface="Arial" panose="020B0604020202020204" pitchFamily="34" charset="0"/>
+              </a:rPr>
+              <a:t> a al </a:t>
+            </a:r>
+            <a:r>
+              <a:rPr lang="en-US" sz="1200" dirty="0" err="1">
+                <a:latin typeface="Arial" panose="020B0604020202020204" pitchFamily="34" charset="0"/>
+                <a:cs typeface="Arial" panose="020B0604020202020204" pitchFamily="34" charset="0"/>
+              </a:rPr>
+              <a:t>índice</a:t>
+            </a:r>
+            <a:r>
+              <a:rPr lang="en-US" sz="1200" dirty="0">
+                <a:latin typeface="Arial" panose="020B0604020202020204" pitchFamily="34" charset="0"/>
+                <a:cs typeface="Arial" panose="020B0604020202020204" pitchFamily="34" charset="0"/>
+              </a:rPr>
+              <a:t> 0,1 y </a:t>
+            </a:r>
+            <a:r>
+              <a:rPr lang="en-US" sz="1200" dirty="0" err="1">
+                <a:latin typeface="Arial" panose="020B0604020202020204" pitchFamily="34" charset="0"/>
+                <a:cs typeface="Arial" panose="020B0604020202020204" pitchFamily="34" charset="0"/>
+              </a:rPr>
+              <a:t>nos</a:t>
+            </a:r>
+            <a:r>
+              <a:rPr lang="en-US" sz="1200" dirty="0">
+                <a:latin typeface="Arial" panose="020B0604020202020204" pitchFamily="34" charset="0"/>
+                <a:cs typeface="Arial" panose="020B0604020202020204" pitchFamily="34" charset="0"/>
+              </a:rPr>
+              <a:t> </a:t>
+            </a:r>
+            <a:r>
+              <a:rPr lang="en-US" sz="1200" dirty="0" err="1">
+                <a:latin typeface="Arial" panose="020B0604020202020204" pitchFamily="34" charset="0"/>
+                <a:cs typeface="Arial" panose="020B0604020202020204" pitchFamily="34" charset="0"/>
+              </a:rPr>
+              <a:t>ayuda</a:t>
+            </a:r>
+            <a:r>
+              <a:rPr lang="en-US" sz="1200" dirty="0">
+                <a:latin typeface="Arial" panose="020B0604020202020204" pitchFamily="34" charset="0"/>
+                <a:cs typeface="Arial" panose="020B0604020202020204" pitchFamily="34" charset="0"/>
+              </a:rPr>
+              <a:t> a </a:t>
+            </a:r>
+            <a:r>
+              <a:rPr lang="en-US" sz="1200" dirty="0" err="1">
+                <a:latin typeface="Arial" panose="020B0604020202020204" pitchFamily="34" charset="0"/>
+                <a:cs typeface="Arial" panose="020B0604020202020204" pitchFamily="34" charset="0"/>
+              </a:rPr>
+              <a:t>comprender</a:t>
+            </a:r>
+            <a:r>
+              <a:rPr lang="en-US" sz="1200" dirty="0">
+                <a:latin typeface="Arial" panose="020B0604020202020204" pitchFamily="34" charset="0"/>
+                <a:cs typeface="Arial" panose="020B0604020202020204" pitchFamily="34" charset="0"/>
+              </a:rPr>
+              <a:t> a </a:t>
+            </a:r>
+            <a:r>
+              <a:rPr lang="en-US" sz="1200" dirty="0" err="1">
+                <a:latin typeface="Arial" panose="020B0604020202020204" pitchFamily="34" charset="0"/>
+                <a:cs typeface="Arial" panose="020B0604020202020204" pitchFamily="34" charset="0"/>
+              </a:rPr>
+              <a:t>primera</a:t>
+            </a:r>
+            <a:r>
+              <a:rPr lang="en-US" sz="1200" dirty="0">
+                <a:latin typeface="Arial" panose="020B0604020202020204" pitchFamily="34" charset="0"/>
+                <a:cs typeface="Arial" panose="020B0604020202020204" pitchFamily="34" charset="0"/>
+              </a:rPr>
+              <a:t> vista la </a:t>
+            </a:r>
+            <a:r>
+              <a:rPr lang="en-US" sz="1200" dirty="0" err="1">
+                <a:latin typeface="Arial" panose="020B0604020202020204" pitchFamily="34" charset="0"/>
+                <a:cs typeface="Arial" panose="020B0604020202020204" pitchFamily="34" charset="0"/>
+              </a:rPr>
+              <a:t>cantidad</a:t>
+            </a:r>
+            <a:r>
+              <a:rPr lang="en-US" sz="1200" dirty="0">
+                <a:latin typeface="Arial" panose="020B0604020202020204" pitchFamily="34" charset="0"/>
+                <a:cs typeface="Arial" panose="020B0604020202020204" pitchFamily="34" charset="0"/>
+              </a:rPr>
+              <a:t> de </a:t>
+            </a:r>
+            <a:r>
+              <a:rPr lang="en-US" sz="1200" dirty="0" err="1">
+                <a:latin typeface="Arial" panose="020B0604020202020204" pitchFamily="34" charset="0"/>
+                <a:cs typeface="Arial" panose="020B0604020202020204" pitchFamily="34" charset="0"/>
+              </a:rPr>
+              <a:t>modos</a:t>
+            </a:r>
+            <a:r>
+              <a:rPr lang="en-US" sz="1200" dirty="0">
+                <a:latin typeface="Arial" panose="020B0604020202020204" pitchFamily="34" charset="0"/>
+                <a:cs typeface="Arial" panose="020B0604020202020204" pitchFamily="34" charset="0"/>
+              </a:rPr>
+              <a:t> </a:t>
+            </a:r>
+            <a:r>
+              <a:rPr lang="en-US" sz="1200" dirty="0" err="1">
+                <a:latin typeface="Arial" panose="020B0604020202020204" pitchFamily="34" charset="0"/>
+                <a:cs typeface="Arial" panose="020B0604020202020204" pitchFamily="34" charset="0"/>
+              </a:rPr>
+              <a:t>que</a:t>
+            </a:r>
+            <a:r>
+              <a:rPr lang="en-US" sz="1200" dirty="0">
+                <a:latin typeface="Arial" panose="020B0604020202020204" pitchFamily="34" charset="0"/>
+                <a:cs typeface="Arial" panose="020B0604020202020204" pitchFamily="34" charset="0"/>
+              </a:rPr>
+              <a:t> </a:t>
+            </a:r>
+            <a:r>
+              <a:rPr lang="en-US" sz="1200" dirty="0" err="1">
+                <a:latin typeface="Arial" panose="020B0604020202020204" pitchFamily="34" charset="0"/>
+                <a:cs typeface="Arial" panose="020B0604020202020204" pitchFamily="34" charset="0"/>
+              </a:rPr>
+              <a:t>puede</a:t>
+            </a:r>
+            <a:r>
+              <a:rPr lang="en-US" sz="1200" dirty="0">
+                <a:latin typeface="Arial" panose="020B0604020202020204" pitchFamily="34" charset="0"/>
+                <a:cs typeface="Arial" panose="020B0604020202020204" pitchFamily="34" charset="0"/>
+              </a:rPr>
+              <a:t> </a:t>
+            </a:r>
+            <a:r>
+              <a:rPr lang="en-US" sz="1200" dirty="0" err="1">
+                <a:latin typeface="Arial" panose="020B0604020202020204" pitchFamily="34" charset="0"/>
+                <a:cs typeface="Arial" panose="020B0604020202020204" pitchFamily="34" charset="0"/>
+              </a:rPr>
+              <a:t>contener</a:t>
+            </a:r>
+            <a:r>
+              <a:rPr lang="en-US" sz="1200" dirty="0">
+                <a:latin typeface="Arial" panose="020B0604020202020204" pitchFamily="34" charset="0"/>
+                <a:cs typeface="Arial" panose="020B0604020202020204" pitchFamily="34" charset="0"/>
+              </a:rPr>
+              <a:t>. De </a:t>
+            </a:r>
+            <a:r>
+              <a:rPr lang="en-US" sz="1200" dirty="0" err="1">
+                <a:latin typeface="Arial" panose="020B0604020202020204" pitchFamily="34" charset="0"/>
+                <a:cs typeface="Arial" panose="020B0604020202020204" pitchFamily="34" charset="0"/>
+              </a:rPr>
+              <a:t>hecho</a:t>
+            </a:r>
+            <a:r>
+              <a:rPr lang="en-US" sz="1200" dirty="0">
+                <a:latin typeface="Arial" panose="020B0604020202020204" pitchFamily="34" charset="0"/>
+                <a:cs typeface="Arial" panose="020B0604020202020204" pitchFamily="34" charset="0"/>
+              </a:rPr>
+              <a:t> </a:t>
+            </a:r>
+            <a:r>
+              <a:rPr lang="en-US" sz="1200" dirty="0" err="1">
+                <a:latin typeface="Arial" panose="020B0604020202020204" pitchFamily="34" charset="0"/>
+                <a:cs typeface="Arial" panose="020B0604020202020204" pitchFamily="34" charset="0"/>
+              </a:rPr>
+              <a:t>en</a:t>
+            </a:r>
+            <a:r>
+              <a:rPr lang="en-US" sz="1200" dirty="0">
+                <a:latin typeface="Arial" panose="020B0604020202020204" pitchFamily="34" charset="0"/>
+                <a:cs typeface="Arial" panose="020B0604020202020204" pitchFamily="34" charset="0"/>
+              </a:rPr>
+              <a:t> la </a:t>
+            </a:r>
+            <a:r>
+              <a:rPr lang="en-US" sz="1200" dirty="0" err="1">
+                <a:latin typeface="Arial" panose="020B0604020202020204" pitchFamily="34" charset="0"/>
+                <a:cs typeface="Arial" panose="020B0604020202020204" pitchFamily="34" charset="0"/>
+              </a:rPr>
+              <a:t>siguiente</a:t>
+            </a:r>
+            <a:r>
+              <a:rPr lang="en-US" sz="1200" dirty="0">
+                <a:latin typeface="Arial" panose="020B0604020202020204" pitchFamily="34" charset="0"/>
+                <a:cs typeface="Arial" panose="020B0604020202020204" pitchFamily="34" charset="0"/>
+              </a:rPr>
+              <a:t> </a:t>
+            </a:r>
+            <a:r>
+              <a:rPr lang="en-US" sz="1200" dirty="0" err="1">
+                <a:latin typeface="Arial" panose="020B0604020202020204" pitchFamily="34" charset="0"/>
+                <a:cs typeface="Arial" panose="020B0604020202020204" pitchFamily="34" charset="0"/>
+              </a:rPr>
+              <a:t>diapositiva</a:t>
+            </a:r>
+            <a:r>
+              <a:rPr lang="en-US" sz="1200" dirty="0">
+                <a:latin typeface="Arial" panose="020B0604020202020204" pitchFamily="34" charset="0"/>
+                <a:cs typeface="Arial" panose="020B0604020202020204" pitchFamily="34" charset="0"/>
+              </a:rPr>
+              <a:t>, se </a:t>
+            </a:r>
+            <a:r>
+              <a:rPr lang="en-US" sz="1200" dirty="0" err="1">
+                <a:latin typeface="Arial" panose="020B0604020202020204" pitchFamily="34" charset="0"/>
+                <a:cs typeface="Arial" panose="020B0604020202020204" pitchFamily="34" charset="0"/>
+              </a:rPr>
+              <a:t>muestra</a:t>
+            </a:r>
+            <a:r>
+              <a:rPr lang="en-US" sz="1200" dirty="0">
+                <a:latin typeface="Arial" panose="020B0604020202020204" pitchFamily="34" charset="0"/>
+                <a:cs typeface="Arial" panose="020B0604020202020204" pitchFamily="34" charset="0"/>
+              </a:rPr>
+              <a:t> la </a:t>
+            </a:r>
+            <a:r>
+              <a:rPr lang="en-US" sz="1200" dirty="0" err="1">
+                <a:latin typeface="Arial" panose="020B0604020202020204" pitchFamily="34" charset="0"/>
+                <a:cs typeface="Arial" panose="020B0604020202020204" pitchFamily="34" charset="0"/>
+              </a:rPr>
+              <a:t>cantidad</a:t>
+            </a:r>
+            <a:r>
+              <a:rPr lang="en-US" sz="1200" dirty="0">
+                <a:latin typeface="Arial" panose="020B0604020202020204" pitchFamily="34" charset="0"/>
+                <a:cs typeface="Arial" panose="020B0604020202020204" pitchFamily="34" charset="0"/>
+              </a:rPr>
+              <a:t> de </a:t>
+            </a:r>
+            <a:r>
+              <a:rPr lang="en-US" sz="1200" dirty="0" err="1">
+                <a:latin typeface="Arial" panose="020B0604020202020204" pitchFamily="34" charset="0"/>
+                <a:cs typeface="Arial" panose="020B0604020202020204" pitchFamily="34" charset="0"/>
+              </a:rPr>
+              <a:t>modos</a:t>
+            </a:r>
+            <a:r>
+              <a:rPr lang="en-US" sz="1200" dirty="0">
+                <a:latin typeface="Arial" panose="020B0604020202020204" pitchFamily="34" charset="0"/>
+                <a:cs typeface="Arial" panose="020B0604020202020204" pitchFamily="34" charset="0"/>
+              </a:rPr>
+              <a:t> </a:t>
+            </a:r>
+            <a:r>
+              <a:rPr lang="en-US" sz="1200" dirty="0" err="1">
+                <a:latin typeface="Arial" panose="020B0604020202020204" pitchFamily="34" charset="0"/>
+                <a:cs typeface="Arial" panose="020B0604020202020204" pitchFamily="34" charset="0"/>
+              </a:rPr>
+              <a:t>totales</a:t>
+            </a:r>
+            <a:r>
+              <a:rPr lang="en-US" sz="1200" dirty="0">
+                <a:latin typeface="Arial" panose="020B0604020202020204" pitchFamily="34" charset="0"/>
+                <a:cs typeface="Arial" panose="020B0604020202020204" pitchFamily="34" charset="0"/>
+              </a:rPr>
+              <a:t>, </a:t>
+            </a:r>
+            <a:r>
+              <a:rPr lang="en-US" sz="1200" dirty="0" err="1">
+                <a:latin typeface="Arial" panose="020B0604020202020204" pitchFamily="34" charset="0"/>
+                <a:cs typeface="Arial" panose="020B0604020202020204" pitchFamily="34" charset="0"/>
+              </a:rPr>
+              <a:t>que</a:t>
+            </a:r>
+            <a:r>
+              <a:rPr lang="en-US" sz="1200" dirty="0">
+                <a:latin typeface="Arial" panose="020B0604020202020204" pitchFamily="34" charset="0"/>
+                <a:cs typeface="Arial" panose="020B0604020202020204" pitchFamily="34" charset="0"/>
+              </a:rPr>
+              <a:t> son </a:t>
+            </a:r>
+            <a:r>
+              <a:rPr lang="en-US" sz="1200" dirty="0" err="1">
+                <a:latin typeface="Arial" panose="020B0604020202020204" pitchFamily="34" charset="0"/>
+                <a:cs typeface="Arial" panose="020B0604020202020204" pitchFamily="34" charset="0"/>
+              </a:rPr>
+              <a:t>todos</a:t>
+            </a:r>
+            <a:r>
+              <a:rPr lang="en-US" sz="1200" dirty="0">
+                <a:latin typeface="Arial" panose="020B0604020202020204" pitchFamily="34" charset="0"/>
+                <a:cs typeface="Arial" panose="020B0604020202020204" pitchFamily="34" charset="0"/>
+              </a:rPr>
+              <a:t> </a:t>
+            </a:r>
+            <a:r>
+              <a:rPr lang="en-US" sz="1200" dirty="0" err="1">
+                <a:latin typeface="Arial" panose="020B0604020202020204" pitchFamily="34" charset="0"/>
+                <a:cs typeface="Arial" panose="020B0604020202020204" pitchFamily="34" charset="0"/>
+              </a:rPr>
+              <a:t>aquellos</a:t>
+            </a:r>
+            <a:r>
+              <a:rPr lang="en-US" sz="1200" dirty="0">
+                <a:latin typeface="Arial" panose="020B0604020202020204" pitchFamily="34" charset="0"/>
+                <a:cs typeface="Arial" panose="020B0604020202020204" pitchFamily="34" charset="0"/>
+              </a:rPr>
+              <a:t> </a:t>
+            </a:r>
+            <a:r>
+              <a:rPr lang="en-US" sz="1200" dirty="0" err="1">
+                <a:latin typeface="Arial" panose="020B0604020202020204" pitchFamily="34" charset="0"/>
+                <a:cs typeface="Arial" panose="020B0604020202020204" pitchFamily="34" charset="0"/>
+              </a:rPr>
+              <a:t>que</a:t>
+            </a:r>
+            <a:r>
+              <a:rPr lang="en-US" sz="1200" dirty="0">
+                <a:latin typeface="Arial" panose="020B0604020202020204" pitchFamily="34" charset="0"/>
+                <a:cs typeface="Arial" panose="020B0604020202020204" pitchFamily="34" charset="0"/>
+              </a:rPr>
+              <a:t> </a:t>
+            </a:r>
+            <a:r>
+              <a:rPr lang="en-US" sz="1200" dirty="0" err="1">
+                <a:latin typeface="Arial" panose="020B0604020202020204" pitchFamily="34" charset="0"/>
+                <a:cs typeface="Arial" panose="020B0604020202020204" pitchFamily="34" charset="0"/>
+              </a:rPr>
+              <a:t>tengan</a:t>
+            </a:r>
+            <a:r>
+              <a:rPr lang="en-US" sz="1200" dirty="0">
+                <a:latin typeface="Arial" panose="020B0604020202020204" pitchFamily="34" charset="0"/>
+                <a:cs typeface="Arial" panose="020B0604020202020204" pitchFamily="34" charset="0"/>
+              </a:rPr>
+              <a:t> un </a:t>
+            </a:r>
+            <a:r>
+              <a:rPr lang="en-US" sz="1200" dirty="0" err="1">
+                <a:latin typeface="Arial" panose="020B0604020202020204" pitchFamily="34" charset="0"/>
+                <a:cs typeface="Arial" panose="020B0604020202020204" pitchFamily="34" charset="0"/>
+              </a:rPr>
+              <a:t>índice</a:t>
+            </a:r>
+            <a:r>
+              <a:rPr lang="en-US" sz="1200" dirty="0">
+                <a:latin typeface="Arial" panose="020B0604020202020204" pitchFamily="34" charset="0"/>
+                <a:cs typeface="Arial" panose="020B0604020202020204" pitchFamily="34" charset="0"/>
+              </a:rPr>
+              <a:t> </a:t>
+            </a:r>
+            <a:r>
+              <a:rPr lang="en-US" sz="1200" dirty="0" err="1">
+                <a:latin typeface="Arial" panose="020B0604020202020204" pitchFamily="34" charset="0"/>
+                <a:cs typeface="Arial" panose="020B0604020202020204" pitchFamily="34" charset="0"/>
+              </a:rPr>
+              <a:t>efectivo</a:t>
+            </a:r>
+            <a:r>
+              <a:rPr lang="en-US" sz="1200" dirty="0">
+                <a:latin typeface="Arial" panose="020B0604020202020204" pitchFamily="34" charset="0"/>
+                <a:cs typeface="Arial" panose="020B0604020202020204" pitchFamily="34" charset="0"/>
+              </a:rPr>
+              <a:t> </a:t>
+            </a:r>
+            <a:r>
+              <a:rPr lang="en-US" sz="1200" dirty="0" err="1">
+                <a:latin typeface="Arial" panose="020B0604020202020204" pitchFamily="34" charset="0"/>
+                <a:cs typeface="Arial" panose="020B0604020202020204" pitchFamily="34" charset="0"/>
+              </a:rPr>
+              <a:t>por</a:t>
+            </a:r>
+            <a:r>
+              <a:rPr lang="en-US" sz="1200" dirty="0">
+                <a:latin typeface="Arial" panose="020B0604020202020204" pitchFamily="34" charset="0"/>
+                <a:cs typeface="Arial" panose="020B0604020202020204" pitchFamily="34" charset="0"/>
+              </a:rPr>
+              <a:t> </a:t>
+            </a:r>
+            <a:r>
+              <a:rPr lang="en-US" sz="1200" dirty="0" err="1">
+                <a:latin typeface="Arial" panose="020B0604020202020204" pitchFamily="34" charset="0"/>
+                <a:cs typeface="Arial" panose="020B0604020202020204" pitchFamily="34" charset="0"/>
+              </a:rPr>
+              <a:t>encima</a:t>
+            </a:r>
+            <a:r>
+              <a:rPr lang="en-US" sz="1200" dirty="0">
+                <a:latin typeface="Arial" panose="020B0604020202020204" pitchFamily="34" charset="0"/>
+                <a:cs typeface="Arial" panose="020B0604020202020204" pitchFamily="34" charset="0"/>
+              </a:rPr>
+              <a:t> del cladding, </a:t>
+            </a:r>
+            <a:r>
+              <a:rPr lang="en-US" sz="1200" dirty="0" err="1">
+                <a:latin typeface="Arial" panose="020B0604020202020204" pitchFamily="34" charset="0"/>
+                <a:cs typeface="Arial" panose="020B0604020202020204" pitchFamily="34" charset="0"/>
+              </a:rPr>
+              <a:t>que</a:t>
+            </a:r>
+            <a:r>
+              <a:rPr lang="en-US" sz="1200" dirty="0">
+                <a:latin typeface="Arial" panose="020B0604020202020204" pitchFamily="34" charset="0"/>
+                <a:cs typeface="Arial" panose="020B0604020202020204" pitchFamily="34" charset="0"/>
+              </a:rPr>
+              <a:t> es de </a:t>
+            </a:r>
+            <a:r>
+              <a:rPr lang="en-US" sz="1200" dirty="0" err="1">
+                <a:latin typeface="Arial" panose="020B0604020202020204" pitchFamily="34" charset="0"/>
+                <a:cs typeface="Arial" panose="020B0604020202020204" pitchFamily="34" charset="0"/>
+              </a:rPr>
+              <a:t>alrededor</a:t>
+            </a:r>
+            <a:r>
+              <a:rPr lang="en-US" sz="1200" dirty="0">
+                <a:latin typeface="Arial" panose="020B0604020202020204" pitchFamily="34" charset="0"/>
+                <a:cs typeface="Arial" panose="020B0604020202020204" pitchFamily="34" charset="0"/>
+              </a:rPr>
+              <a:t> de 1.44.</a:t>
+            </a:r>
           </a:p>
           <a:p>
             <a:pPr algn="just"/>
@@ -3565,6 +4497,126 @@
           </a:p>
         </p:txBody>
       </p:sp>
+      <p:pic>
+        <p:nvPicPr>
+          <p:cNvPr id="6" name="Imagen 5" descr="Interfaz de usuario gráfica, Aplicación, Word&#10;&#10;El contenido generado por IA puede ser incorrecto.">
+            <a:extLst>
+              <a:ext uri="{FF2B5EF4-FFF2-40B4-BE49-F238E27FC236}">
+                <a16:creationId xmlns:a16="http://schemas.microsoft.com/office/drawing/2014/main" id="{FA5EB026-0DB9-10CC-CAAB-2133E01A0A44}"/>
+              </a:ext>
+            </a:extLst>
+          </p:cNvPr>
+          <p:cNvPicPr>
+            <a:picLocks noChangeAspect="1"/>
+          </p:cNvPicPr>
+          <p:nvPr/>
+        </p:nvPicPr>
+        <p:blipFill>
+          <a:blip r:embed="rId5"/>
+          <a:stretch>
+            <a:fillRect/>
+          </a:stretch>
+        </p:blipFill>
+        <p:spPr>
+          <a:xfrm>
+            <a:off x="608012" y="1009948"/>
+            <a:ext cx="3119567" cy="2266652"/>
+          </a:xfrm>
+          <a:prstGeom prst="rect">
+            <a:avLst/>
+          </a:prstGeom>
+        </p:spPr>
+      </p:pic>
+      <p:pic>
+        <p:nvPicPr>
+          <p:cNvPr id="8" name="Imagen 7" descr="Interfaz de usuario gráfica, Word&#10;&#10;El contenido generado por IA puede ser incorrecto.">
+            <a:extLst>
+              <a:ext uri="{FF2B5EF4-FFF2-40B4-BE49-F238E27FC236}">
+                <a16:creationId xmlns:a16="http://schemas.microsoft.com/office/drawing/2014/main" id="{035CD8B0-26E9-5EDB-2EDF-AA9F3A3B9C05}"/>
+              </a:ext>
+            </a:extLst>
+          </p:cNvPr>
+          <p:cNvPicPr>
+            <a:picLocks noChangeAspect="1"/>
+          </p:cNvPicPr>
+          <p:nvPr/>
+        </p:nvPicPr>
+        <p:blipFill>
+          <a:blip r:embed="rId6"/>
+          <a:stretch>
+            <a:fillRect/>
+          </a:stretch>
+        </p:blipFill>
+        <p:spPr>
+          <a:xfrm>
+            <a:off x="4343400" y="1073407"/>
+            <a:ext cx="3121505" cy="2203193"/>
+          </a:xfrm>
+          <a:prstGeom prst="rect">
+            <a:avLst/>
+          </a:prstGeom>
+        </p:spPr>
+      </p:pic>
+      <p:pic>
+        <p:nvPicPr>
+          <p:cNvPr id="10" name="Imagen 9" descr="Interfaz de usuario gráfica, Aplicación&#10;&#10;El contenido generado por IA puede ser incorrecto.">
+            <a:extLst>
+              <a:ext uri="{FF2B5EF4-FFF2-40B4-BE49-F238E27FC236}">
+                <a16:creationId xmlns:a16="http://schemas.microsoft.com/office/drawing/2014/main" id="{3F3FF10B-6C4F-633A-81DD-FB844A482D76}"/>
+              </a:ext>
+            </a:extLst>
+          </p:cNvPr>
+          <p:cNvPicPr>
+            <a:picLocks noChangeAspect="1"/>
+          </p:cNvPicPr>
+          <p:nvPr/>
+        </p:nvPicPr>
+        <p:blipFill>
+          <a:blip r:embed="rId7"/>
+          <a:stretch>
+            <a:fillRect/>
+          </a:stretch>
+        </p:blipFill>
+        <p:spPr>
+          <a:xfrm>
+            <a:off x="7954927" y="1024007"/>
+            <a:ext cx="3213038" cy="2218526"/>
+          </a:xfrm>
+          <a:prstGeom prst="rect">
+            <a:avLst/>
+          </a:prstGeom>
+        </p:spPr>
+      </p:pic>
+      <p:pic>
+        <p:nvPicPr>
+          <p:cNvPr id="12" name="Imagen 11" descr="Texto&#10;&#10;El contenido generado por IA puede ser incorrecto.">
+            <a:extLst>
+              <a:ext uri="{FF2B5EF4-FFF2-40B4-BE49-F238E27FC236}">
+                <a16:creationId xmlns:a16="http://schemas.microsoft.com/office/drawing/2014/main" id="{1465DDA4-B361-95CF-47C3-A7DF719052C0}"/>
+              </a:ext>
+            </a:extLst>
+          </p:cNvPr>
+          <p:cNvPicPr>
+            <a:picLocks noChangeAspect="1"/>
+          </p:cNvPicPr>
+          <p:nvPr/>
+        </p:nvPicPr>
+        <p:blipFill>
+          <a:blip r:embed="rId8"/>
+          <a:stretch>
+            <a:fillRect/>
+          </a:stretch>
+        </p:blipFill>
+        <p:spPr>
+          <a:xfrm>
+            <a:off x="633412" y="3328120"/>
+            <a:ext cx="8202170" cy="1257475"/>
+          </a:xfrm>
+          <a:prstGeom prst="rect">
+            <a:avLst/>
+          </a:prstGeom>
+        </p:spPr>
+      </p:pic>
     </p:spTree>
     <p:extLst>
       <p:ext uri="{BB962C8B-B14F-4D97-AF65-F5344CB8AC3E}">
@@ -3583,6 +4635,2332 @@
   <p:cSld>
     <p:spTree>
       <p:nvGrpSpPr>
+        <p:cNvPr id="1" name="">
+          <a:extLst>
+            <a:ext uri="{FF2B5EF4-FFF2-40B4-BE49-F238E27FC236}">
+              <a16:creationId xmlns:a16="http://schemas.microsoft.com/office/drawing/2014/main" id="{5479C3DF-5152-5C28-897E-3ED37CEB2D56}"/>
+            </a:ext>
+          </a:extLst>
+        </p:cNvPr>
+        <p:cNvGrpSpPr/>
+        <p:nvPr/>
+      </p:nvGrpSpPr>
+      <p:grpSpPr>
+        <a:xfrm>
+          <a:off x="0" y="0"/>
+          <a:ext cx="0" cy="0"/>
+          <a:chOff x="0" y="0"/>
+          <a:chExt cx="0" cy="0"/>
+        </a:xfrm>
+      </p:grpSpPr>
+      <p:sp>
+        <p:nvSpPr>
+          <p:cNvPr id="16" name="object 16">
+            <a:extLst>
+              <a:ext uri="{FF2B5EF4-FFF2-40B4-BE49-F238E27FC236}">
+                <a16:creationId xmlns:a16="http://schemas.microsoft.com/office/drawing/2014/main" id="{3114E14B-F648-6920-5950-B939AD4413B6}"/>
+              </a:ext>
+            </a:extLst>
+          </p:cNvPr>
+          <p:cNvSpPr txBox="1">
+            <a:spLocks noGrp="1"/>
+          </p:cNvSpPr>
+          <p:nvPr>
+            <p:ph type="title"/>
+          </p:nvPr>
+        </p:nvSpPr>
+        <p:spPr>
+          <a:xfrm>
+            <a:off x="685800" y="408883"/>
+            <a:ext cx="10994410" cy="397545"/>
+          </a:xfrm>
+          <a:prstGeom prst="rect">
+            <a:avLst/>
+          </a:prstGeom>
+        </p:spPr>
+        <p:txBody>
+          <a:bodyPr vert="horz" wrap="square" lIns="0" tIns="12700" rIns="0" bIns="0" rtlCol="0">
+            <a:spAutoFit/>
+          </a:bodyPr>
+          <a:lstStyle/>
+          <a:p>
+            <a:pPr marL="12700">
+              <a:lnSpc>
+                <a:spcPct val="100000"/>
+              </a:lnSpc>
+              <a:spcBef>
+                <a:spcPts val="100"/>
+              </a:spcBef>
+            </a:pPr>
+            <a:r>
+              <a:rPr lang="en-US" sz="2500" dirty="0"/>
+              <a:t>Learning outcome #2 – Multimode Interference (MMI) Coupler cross-section</a:t>
+            </a:r>
+            <a:endParaRPr lang="en-US" sz="2500" b="0" dirty="0">
+              <a:latin typeface="+mj-lt"/>
+              <a:cs typeface="Lucida Sans"/>
+            </a:endParaRPr>
+          </a:p>
+        </p:txBody>
+      </p:sp>
+      <p:pic>
+        <p:nvPicPr>
+          <p:cNvPr id="83" name="Gráfico 82">
+            <a:extLst>
+              <a:ext uri="{FF2B5EF4-FFF2-40B4-BE49-F238E27FC236}">
+                <a16:creationId xmlns:a16="http://schemas.microsoft.com/office/drawing/2014/main" id="{59A6388A-B489-BA84-890C-026E2B988F95}"/>
+              </a:ext>
+            </a:extLst>
+          </p:cNvPr>
+          <p:cNvPicPr>
+            <a:picLocks noChangeAspect="1"/>
+          </p:cNvPicPr>
+          <p:nvPr/>
+        </p:nvPicPr>
+        <p:blipFill>
+          <a:blip r:embed="rId3">
+            <a:extLst>
+              <a:ext uri="{96DAC541-7B7A-43D3-8B79-37D633B846F1}">
+                <asvg:svgBlip xmlns:asvg="http://schemas.microsoft.com/office/drawing/2016/SVG/main" r:embed="rId4"/>
+              </a:ext>
+            </a:extLst>
+          </a:blip>
+          <a:stretch>
+            <a:fillRect/>
+          </a:stretch>
+        </p:blipFill>
+        <p:spPr>
+          <a:xfrm>
+            <a:off x="5045006" y="6356057"/>
+            <a:ext cx="6409575" cy="363174"/>
+          </a:xfrm>
+          <a:prstGeom prst="rect">
+            <a:avLst/>
+          </a:prstGeom>
+        </p:spPr>
+      </p:pic>
+      <p:sp>
+        <p:nvSpPr>
+          <p:cNvPr id="84" name="Marcador de número de diapositiva 83">
+            <a:extLst>
+              <a:ext uri="{FF2B5EF4-FFF2-40B4-BE49-F238E27FC236}">
+                <a16:creationId xmlns:a16="http://schemas.microsoft.com/office/drawing/2014/main" id="{859A2540-058D-F57C-A2C2-B9A17E34F865}"/>
+              </a:ext>
+            </a:extLst>
+          </p:cNvPr>
+          <p:cNvSpPr>
+            <a:spLocks noGrp="1"/>
+          </p:cNvSpPr>
+          <p:nvPr>
+            <p:ph type="sldNum" sz="quarter" idx="7"/>
+          </p:nvPr>
+        </p:nvSpPr>
+        <p:spPr/>
+        <p:txBody>
+          <a:bodyPr/>
+          <a:lstStyle/>
+          <a:p>
+            <a:fld id="{B6F15528-21DE-4FAA-801E-634DDDAF4B2B}" type="slidenum">
+              <a:rPr lang="es-ES" smtClean="0"/>
+              <a:t>11</a:t>
+            </a:fld>
+            <a:endParaRPr lang="es-ES"/>
+          </a:p>
+        </p:txBody>
+      </p:sp>
+      <p:sp>
+        <p:nvSpPr>
+          <p:cNvPr id="3" name="Marcador de pie de página 2">
+            <a:extLst>
+              <a:ext uri="{FF2B5EF4-FFF2-40B4-BE49-F238E27FC236}">
+                <a16:creationId xmlns:a16="http://schemas.microsoft.com/office/drawing/2014/main" id="{B4902674-FF7E-F050-6B20-D56854906AA9}"/>
+              </a:ext>
+            </a:extLst>
+          </p:cNvPr>
+          <p:cNvSpPr>
+            <a:spLocks noGrp="1"/>
+          </p:cNvSpPr>
+          <p:nvPr>
+            <p:ph type="ftr" sz="quarter" idx="5"/>
+          </p:nvPr>
+        </p:nvSpPr>
+        <p:spPr/>
+        <p:txBody>
+          <a:bodyPr/>
+          <a:lstStyle/>
+          <a:p>
+            <a:pPr marL="12700">
+              <a:spcBef>
+                <a:spcPts val="15"/>
+              </a:spcBef>
+            </a:pPr>
+            <a:r>
+              <a:rPr lang="es-ES" spc="-5"/>
+              <a:t>LAB 0.2. COUPLERS</a:t>
+            </a:r>
+            <a:endParaRPr lang="es-ES" spc="-5" dirty="0"/>
+          </a:p>
+        </p:txBody>
+      </p:sp>
+      <p:sp>
+        <p:nvSpPr>
+          <p:cNvPr id="4" name="Marcador de texto 2">
+            <a:extLst>
+              <a:ext uri="{FF2B5EF4-FFF2-40B4-BE49-F238E27FC236}">
+                <a16:creationId xmlns:a16="http://schemas.microsoft.com/office/drawing/2014/main" id="{31B9BE38-81B3-8F74-EBA3-2D16488A0F3D}"/>
+              </a:ext>
+            </a:extLst>
+          </p:cNvPr>
+          <p:cNvSpPr txBox="1">
+            <a:spLocks/>
+          </p:cNvSpPr>
+          <p:nvPr/>
+        </p:nvSpPr>
+        <p:spPr>
+          <a:xfrm>
+            <a:off x="608012" y="1295400"/>
+            <a:ext cx="11048999" cy="4958137"/>
+          </a:xfrm>
+          <a:prstGeom prst="rect">
+            <a:avLst/>
+          </a:prstGeom>
+        </p:spPr>
+        <p:txBody>
+          <a:bodyPr>
+            <a:normAutofit/>
+          </a:bodyPr>
+          <a:lstStyle>
+            <a:lvl1pPr marL="0">
+              <a:defRPr>
+                <a:latin typeface="+mn-lt"/>
+                <a:ea typeface="+mn-ea"/>
+                <a:cs typeface="+mn-cs"/>
+              </a:defRPr>
+            </a:lvl1pPr>
+            <a:lvl2pPr marL="457200">
+              <a:defRPr>
+                <a:latin typeface="+mn-lt"/>
+                <a:ea typeface="+mn-ea"/>
+                <a:cs typeface="+mn-cs"/>
+              </a:defRPr>
+            </a:lvl2pPr>
+            <a:lvl3pPr marL="914400">
+              <a:defRPr>
+                <a:latin typeface="+mn-lt"/>
+                <a:ea typeface="+mn-ea"/>
+                <a:cs typeface="+mn-cs"/>
+              </a:defRPr>
+            </a:lvl3pPr>
+            <a:lvl4pPr marL="1371600">
+              <a:defRPr>
+                <a:latin typeface="+mn-lt"/>
+                <a:ea typeface="+mn-ea"/>
+                <a:cs typeface="+mn-cs"/>
+              </a:defRPr>
+            </a:lvl4pPr>
+            <a:lvl5pPr marL="1828800">
+              <a:defRPr>
+                <a:latin typeface="+mn-lt"/>
+                <a:ea typeface="+mn-ea"/>
+                <a:cs typeface="+mn-cs"/>
+              </a:defRPr>
+            </a:lvl5pPr>
+            <a:lvl6pPr marL="2286000">
+              <a:defRPr>
+                <a:latin typeface="+mn-lt"/>
+                <a:ea typeface="+mn-ea"/>
+                <a:cs typeface="+mn-cs"/>
+              </a:defRPr>
+            </a:lvl6pPr>
+            <a:lvl7pPr marL="2743200">
+              <a:defRPr>
+                <a:latin typeface="+mn-lt"/>
+                <a:ea typeface="+mn-ea"/>
+                <a:cs typeface="+mn-cs"/>
+              </a:defRPr>
+            </a:lvl7pPr>
+            <a:lvl8pPr marL="3200400">
+              <a:defRPr>
+                <a:latin typeface="+mn-lt"/>
+                <a:ea typeface="+mn-ea"/>
+                <a:cs typeface="+mn-cs"/>
+              </a:defRPr>
+            </a:lvl8pPr>
+            <a:lvl9pPr marL="3657600">
+              <a:defRPr>
+                <a:latin typeface="+mn-lt"/>
+                <a:ea typeface="+mn-ea"/>
+                <a:cs typeface="+mn-cs"/>
+              </a:defRPr>
+            </a:lvl9pPr>
+          </a:lstStyle>
+          <a:p>
+            <a:pPr algn="just"/>
+            <a:endParaRPr lang="en-US" sz="2000" b="1" i="1" u="sng" dirty="0"/>
+          </a:p>
+          <a:p>
+            <a:pPr algn="just"/>
+            <a:endParaRPr lang="en-US" sz="2000" kern="0" dirty="0">
+              <a:solidFill>
+                <a:sysClr val="windowText" lastClr="000000"/>
+              </a:solidFill>
+            </a:endParaRPr>
+          </a:p>
+        </p:txBody>
+      </p:sp>
+      <p:sp>
+        <p:nvSpPr>
+          <p:cNvPr id="2" name="CuadroTexto 1">
+            <a:extLst>
+              <a:ext uri="{FF2B5EF4-FFF2-40B4-BE49-F238E27FC236}">
+                <a16:creationId xmlns:a16="http://schemas.microsoft.com/office/drawing/2014/main" id="{AA84280D-068F-A002-ADF9-6B048D49759C}"/>
+              </a:ext>
+            </a:extLst>
+          </p:cNvPr>
+          <p:cNvSpPr txBox="1"/>
+          <p:nvPr/>
+        </p:nvSpPr>
+        <p:spPr>
+          <a:xfrm>
+            <a:off x="608012" y="4903378"/>
+            <a:ext cx="11199971" cy="1938992"/>
+          </a:xfrm>
+          <a:prstGeom prst="rect">
+            <a:avLst/>
+          </a:prstGeom>
+          <a:solidFill>
+            <a:schemeClr val="bg1">
+              <a:lumMod val="95000"/>
+            </a:schemeClr>
+          </a:solidFill>
+          <a:ln w="28575">
+            <a:solidFill>
+              <a:srgbClr val="E0700D"/>
+            </a:solidFill>
+          </a:ln>
+        </p:spPr>
+        <p:txBody>
+          <a:bodyPr wrap="square" rtlCol="0">
+            <a:spAutoFit/>
+          </a:bodyPr>
+          <a:lstStyle/>
+          <a:p>
+            <a:pPr algn="just"/>
+            <a:r>
+              <a:rPr lang="en-US" sz="1200" dirty="0">
+                <a:latin typeface="Arial" panose="020B0604020202020204" pitchFamily="34" charset="0"/>
+                <a:cs typeface="Arial" panose="020B0604020202020204" pitchFamily="34" charset="0"/>
+              </a:rPr>
+              <a:t>Los MMI se </a:t>
+            </a:r>
+            <a:r>
+              <a:rPr lang="en-US" sz="1200" dirty="0" err="1">
+                <a:latin typeface="Arial" panose="020B0604020202020204" pitchFamily="34" charset="0"/>
+                <a:cs typeface="Arial" panose="020B0604020202020204" pitchFamily="34" charset="0"/>
+              </a:rPr>
+              <a:t>caracterizan</a:t>
+            </a:r>
+            <a:r>
+              <a:rPr lang="en-US" sz="1200" dirty="0">
+                <a:latin typeface="Arial" panose="020B0604020202020204" pitchFamily="34" charset="0"/>
+                <a:cs typeface="Arial" panose="020B0604020202020204" pitchFamily="34" charset="0"/>
+              </a:rPr>
+              <a:t> </a:t>
+            </a:r>
+            <a:r>
+              <a:rPr lang="en-US" sz="1200" dirty="0" err="1">
+                <a:latin typeface="Arial" panose="020B0604020202020204" pitchFamily="34" charset="0"/>
+                <a:cs typeface="Arial" panose="020B0604020202020204" pitchFamily="34" charset="0"/>
+              </a:rPr>
+              <a:t>por</a:t>
+            </a:r>
+            <a:r>
+              <a:rPr lang="en-US" sz="1200" dirty="0">
+                <a:latin typeface="Arial" panose="020B0604020202020204" pitchFamily="34" charset="0"/>
+                <a:cs typeface="Arial" panose="020B0604020202020204" pitchFamily="34" charset="0"/>
+              </a:rPr>
+              <a:t> la replica de </a:t>
+            </a:r>
+            <a:r>
+              <a:rPr lang="en-US" sz="1200" dirty="0" err="1">
+                <a:latin typeface="Arial" panose="020B0604020202020204" pitchFamily="34" charset="0"/>
+                <a:cs typeface="Arial" panose="020B0604020202020204" pitchFamily="34" charset="0"/>
+              </a:rPr>
+              <a:t>autoimágenes</a:t>
+            </a:r>
+            <a:r>
+              <a:rPr lang="en-US" sz="1200" dirty="0">
+                <a:latin typeface="Arial" panose="020B0604020202020204" pitchFamily="34" charset="0"/>
+                <a:cs typeface="Arial" panose="020B0604020202020204" pitchFamily="34" charset="0"/>
+              </a:rPr>
+              <a:t> </a:t>
+            </a:r>
+            <a:r>
+              <a:rPr lang="en-US" sz="1200" dirty="0" err="1">
+                <a:latin typeface="Arial" panose="020B0604020202020204" pitchFamily="34" charset="0"/>
+                <a:cs typeface="Arial" panose="020B0604020202020204" pitchFamily="34" charset="0"/>
+              </a:rPr>
+              <a:t>por</a:t>
+            </a:r>
+            <a:r>
+              <a:rPr lang="en-US" sz="1200" dirty="0">
+                <a:latin typeface="Arial" panose="020B0604020202020204" pitchFamily="34" charset="0"/>
+                <a:cs typeface="Arial" panose="020B0604020202020204" pitchFamily="34" charset="0"/>
+              </a:rPr>
+              <a:t> medio de la </a:t>
+            </a:r>
+            <a:r>
+              <a:rPr lang="en-US" sz="1200" dirty="0" err="1">
+                <a:latin typeface="Arial" panose="020B0604020202020204" pitchFamily="34" charset="0"/>
+                <a:cs typeface="Arial" panose="020B0604020202020204" pitchFamily="34" charset="0"/>
+              </a:rPr>
+              <a:t>interferencia</a:t>
+            </a:r>
+            <a:r>
+              <a:rPr lang="en-US" sz="1200" dirty="0">
+                <a:latin typeface="Arial" panose="020B0604020202020204" pitchFamily="34" charset="0"/>
+                <a:cs typeface="Arial" panose="020B0604020202020204" pitchFamily="34" charset="0"/>
+              </a:rPr>
+              <a:t> entre </a:t>
+            </a:r>
+            <a:r>
+              <a:rPr lang="en-US" sz="1200" dirty="0" err="1">
+                <a:latin typeface="Arial" panose="020B0604020202020204" pitchFamily="34" charset="0"/>
+                <a:cs typeface="Arial" panose="020B0604020202020204" pitchFamily="34" charset="0"/>
+              </a:rPr>
+              <a:t>los</a:t>
+            </a:r>
+            <a:r>
+              <a:rPr lang="en-US" sz="1200" dirty="0">
+                <a:latin typeface="Arial" panose="020B0604020202020204" pitchFamily="34" charset="0"/>
+                <a:cs typeface="Arial" panose="020B0604020202020204" pitchFamily="34" charset="0"/>
+              </a:rPr>
+              <a:t> </a:t>
+            </a:r>
+            <a:r>
+              <a:rPr lang="en-US" sz="1200" dirty="0" err="1">
+                <a:latin typeface="Arial" panose="020B0604020202020204" pitchFamily="34" charset="0"/>
+                <a:cs typeface="Arial" panose="020B0604020202020204" pitchFamily="34" charset="0"/>
+              </a:rPr>
+              <a:t>modos</a:t>
+            </a:r>
+            <a:r>
+              <a:rPr lang="en-US" sz="1200" dirty="0">
+                <a:latin typeface="Arial" panose="020B0604020202020204" pitchFamily="34" charset="0"/>
+                <a:cs typeface="Arial" panose="020B0604020202020204" pitchFamily="34" charset="0"/>
+              </a:rPr>
+              <a:t>. Al ser de gran </a:t>
+            </a:r>
+            <a:r>
+              <a:rPr lang="en-US" sz="1200" dirty="0" err="1">
+                <a:latin typeface="Arial" panose="020B0604020202020204" pitchFamily="34" charset="0"/>
+                <a:cs typeface="Arial" panose="020B0604020202020204" pitchFamily="34" charset="0"/>
+              </a:rPr>
+              <a:t>tamaño</a:t>
+            </a:r>
+            <a:r>
+              <a:rPr lang="en-US" sz="1200" dirty="0">
+                <a:latin typeface="Arial" panose="020B0604020202020204" pitchFamily="34" charset="0"/>
+                <a:cs typeface="Arial" panose="020B0604020202020204" pitchFamily="34" charset="0"/>
+              </a:rPr>
+              <a:t> se </a:t>
+            </a:r>
+            <a:r>
+              <a:rPr lang="en-US" sz="1200" dirty="0" err="1">
+                <a:latin typeface="Arial" panose="020B0604020202020204" pitchFamily="34" charset="0"/>
+                <a:cs typeface="Arial" panose="020B0604020202020204" pitchFamily="34" charset="0"/>
+              </a:rPr>
+              <a:t>propagan</a:t>
+            </a:r>
+            <a:r>
+              <a:rPr lang="en-US" sz="1200" dirty="0">
+                <a:latin typeface="Arial" panose="020B0604020202020204" pitchFamily="34" charset="0"/>
+                <a:cs typeface="Arial" panose="020B0604020202020204" pitchFamily="34" charset="0"/>
+              </a:rPr>
+              <a:t> </a:t>
+            </a:r>
+            <a:r>
+              <a:rPr lang="en-US" sz="1200" dirty="0" err="1">
+                <a:latin typeface="Arial" panose="020B0604020202020204" pitchFamily="34" charset="0"/>
+                <a:cs typeface="Arial" panose="020B0604020202020204" pitchFamily="34" charset="0"/>
+              </a:rPr>
+              <a:t>una</a:t>
+            </a:r>
+            <a:r>
+              <a:rPr lang="en-US" sz="1200" dirty="0">
+                <a:latin typeface="Arial" panose="020B0604020202020204" pitchFamily="34" charset="0"/>
+                <a:cs typeface="Arial" panose="020B0604020202020204" pitchFamily="34" charset="0"/>
+              </a:rPr>
+              <a:t> gran </a:t>
+            </a:r>
+            <a:r>
+              <a:rPr lang="en-US" sz="1200" dirty="0" err="1">
+                <a:latin typeface="Arial" panose="020B0604020202020204" pitchFamily="34" charset="0"/>
+                <a:cs typeface="Arial" panose="020B0604020202020204" pitchFamily="34" charset="0"/>
+              </a:rPr>
+              <a:t>cantidad</a:t>
+            </a:r>
+            <a:r>
+              <a:rPr lang="en-US" sz="1200" dirty="0">
+                <a:latin typeface="Arial" panose="020B0604020202020204" pitchFamily="34" charset="0"/>
+                <a:cs typeface="Arial" panose="020B0604020202020204" pitchFamily="34" charset="0"/>
+              </a:rPr>
+              <a:t> de </a:t>
+            </a:r>
+            <a:r>
+              <a:rPr lang="en-US" sz="1200" dirty="0" err="1">
+                <a:latin typeface="Arial" panose="020B0604020202020204" pitchFamily="34" charset="0"/>
+                <a:cs typeface="Arial" panose="020B0604020202020204" pitchFamily="34" charset="0"/>
+              </a:rPr>
+              <a:t>modos</a:t>
+            </a:r>
+            <a:r>
+              <a:rPr lang="en-US" sz="1200" dirty="0">
+                <a:latin typeface="Arial" panose="020B0604020202020204" pitchFamily="34" charset="0"/>
+                <a:cs typeface="Arial" panose="020B0604020202020204" pitchFamily="34" charset="0"/>
+              </a:rPr>
+              <a:t>. Las </a:t>
+            </a:r>
+            <a:r>
+              <a:rPr lang="en-US" sz="1200" dirty="0" err="1">
+                <a:latin typeface="Arial" panose="020B0604020202020204" pitchFamily="34" charset="0"/>
+                <a:cs typeface="Arial" panose="020B0604020202020204" pitchFamily="34" charset="0"/>
+              </a:rPr>
+              <a:t>imágenes</a:t>
+            </a:r>
+            <a:r>
+              <a:rPr lang="en-US" sz="1200" dirty="0">
+                <a:latin typeface="Arial" panose="020B0604020202020204" pitchFamily="34" charset="0"/>
+                <a:cs typeface="Arial" panose="020B0604020202020204" pitchFamily="34" charset="0"/>
+              </a:rPr>
+              <a:t> </a:t>
+            </a:r>
+            <a:r>
+              <a:rPr lang="en-US" sz="1200" dirty="0" err="1">
+                <a:latin typeface="Arial" panose="020B0604020202020204" pitchFamily="34" charset="0"/>
+                <a:cs typeface="Arial" panose="020B0604020202020204" pitchFamily="34" charset="0"/>
+              </a:rPr>
+              <a:t>correspondientes</a:t>
+            </a:r>
+            <a:r>
+              <a:rPr lang="en-US" sz="1200" dirty="0">
+                <a:latin typeface="Arial" panose="020B0604020202020204" pitchFamily="34" charset="0"/>
+                <a:cs typeface="Arial" panose="020B0604020202020204" pitchFamily="34" charset="0"/>
+              </a:rPr>
+              <a:t> a </a:t>
+            </a:r>
+            <a:r>
+              <a:rPr lang="en-US" sz="1200" dirty="0" err="1">
+                <a:latin typeface="Arial" panose="020B0604020202020204" pitchFamily="34" charset="0"/>
+                <a:cs typeface="Arial" panose="020B0604020202020204" pitchFamily="34" charset="0"/>
+              </a:rPr>
+              <a:t>modos</a:t>
+            </a:r>
+            <a:r>
+              <a:rPr lang="en-US" sz="1200" dirty="0">
+                <a:latin typeface="Arial" panose="020B0604020202020204" pitchFamily="34" charset="0"/>
+                <a:cs typeface="Arial" panose="020B0604020202020204" pitchFamily="34" charset="0"/>
+              </a:rPr>
+              <a:t> TE, </a:t>
+            </a:r>
+            <a:r>
+              <a:rPr lang="en-US" sz="1200" dirty="0" err="1">
+                <a:latin typeface="Arial" panose="020B0604020202020204" pitchFamily="34" charset="0"/>
+                <a:cs typeface="Arial" panose="020B0604020202020204" pitchFamily="34" charset="0"/>
+              </a:rPr>
+              <a:t>correspondientes</a:t>
+            </a:r>
+            <a:r>
+              <a:rPr lang="en-US" sz="1200" dirty="0">
+                <a:latin typeface="Arial" panose="020B0604020202020204" pitchFamily="34" charset="0"/>
+                <a:cs typeface="Arial" panose="020B0604020202020204" pitchFamily="34" charset="0"/>
+              </a:rPr>
+              <a:t> a al </a:t>
+            </a:r>
+            <a:r>
+              <a:rPr lang="en-US" sz="1200" dirty="0" err="1">
+                <a:latin typeface="Arial" panose="020B0604020202020204" pitchFamily="34" charset="0"/>
+                <a:cs typeface="Arial" panose="020B0604020202020204" pitchFamily="34" charset="0"/>
+              </a:rPr>
+              <a:t>índice</a:t>
+            </a:r>
+            <a:r>
+              <a:rPr lang="en-US" sz="1200" dirty="0">
+                <a:latin typeface="Arial" panose="020B0604020202020204" pitchFamily="34" charset="0"/>
+                <a:cs typeface="Arial" panose="020B0604020202020204" pitchFamily="34" charset="0"/>
+              </a:rPr>
+              <a:t> 0,1 y </a:t>
+            </a:r>
+            <a:r>
+              <a:rPr lang="en-US" sz="1200" dirty="0" err="1">
+                <a:latin typeface="Arial" panose="020B0604020202020204" pitchFamily="34" charset="0"/>
+                <a:cs typeface="Arial" panose="020B0604020202020204" pitchFamily="34" charset="0"/>
+              </a:rPr>
+              <a:t>nos</a:t>
+            </a:r>
+            <a:r>
+              <a:rPr lang="en-US" sz="1200" dirty="0">
+                <a:latin typeface="Arial" panose="020B0604020202020204" pitchFamily="34" charset="0"/>
+                <a:cs typeface="Arial" panose="020B0604020202020204" pitchFamily="34" charset="0"/>
+              </a:rPr>
+              <a:t> </a:t>
+            </a:r>
+            <a:r>
+              <a:rPr lang="en-US" sz="1200" dirty="0" err="1">
+                <a:latin typeface="Arial" panose="020B0604020202020204" pitchFamily="34" charset="0"/>
+                <a:cs typeface="Arial" panose="020B0604020202020204" pitchFamily="34" charset="0"/>
+              </a:rPr>
+              <a:t>ayuda</a:t>
+            </a:r>
+            <a:r>
+              <a:rPr lang="en-US" sz="1200" dirty="0">
+                <a:latin typeface="Arial" panose="020B0604020202020204" pitchFamily="34" charset="0"/>
+                <a:cs typeface="Arial" panose="020B0604020202020204" pitchFamily="34" charset="0"/>
+              </a:rPr>
+              <a:t> a </a:t>
+            </a:r>
+            <a:r>
+              <a:rPr lang="en-US" sz="1200" dirty="0" err="1">
+                <a:latin typeface="Arial" panose="020B0604020202020204" pitchFamily="34" charset="0"/>
+                <a:cs typeface="Arial" panose="020B0604020202020204" pitchFamily="34" charset="0"/>
+              </a:rPr>
+              <a:t>comprender</a:t>
+            </a:r>
+            <a:r>
+              <a:rPr lang="en-US" sz="1200" dirty="0">
+                <a:latin typeface="Arial" panose="020B0604020202020204" pitchFamily="34" charset="0"/>
+                <a:cs typeface="Arial" panose="020B0604020202020204" pitchFamily="34" charset="0"/>
+              </a:rPr>
+              <a:t> a </a:t>
+            </a:r>
+            <a:r>
+              <a:rPr lang="en-US" sz="1200" dirty="0" err="1">
+                <a:latin typeface="Arial" panose="020B0604020202020204" pitchFamily="34" charset="0"/>
+                <a:cs typeface="Arial" panose="020B0604020202020204" pitchFamily="34" charset="0"/>
+              </a:rPr>
+              <a:t>primera</a:t>
+            </a:r>
+            <a:r>
+              <a:rPr lang="en-US" sz="1200" dirty="0">
+                <a:latin typeface="Arial" panose="020B0604020202020204" pitchFamily="34" charset="0"/>
+                <a:cs typeface="Arial" panose="020B0604020202020204" pitchFamily="34" charset="0"/>
+              </a:rPr>
+              <a:t> vista la </a:t>
+            </a:r>
+            <a:r>
+              <a:rPr lang="en-US" sz="1200" dirty="0" err="1">
+                <a:latin typeface="Arial" panose="020B0604020202020204" pitchFamily="34" charset="0"/>
+                <a:cs typeface="Arial" panose="020B0604020202020204" pitchFamily="34" charset="0"/>
+              </a:rPr>
+              <a:t>cantidad</a:t>
+            </a:r>
+            <a:r>
+              <a:rPr lang="en-US" sz="1200" dirty="0">
+                <a:latin typeface="Arial" panose="020B0604020202020204" pitchFamily="34" charset="0"/>
+                <a:cs typeface="Arial" panose="020B0604020202020204" pitchFamily="34" charset="0"/>
+              </a:rPr>
+              <a:t> de </a:t>
+            </a:r>
+            <a:r>
+              <a:rPr lang="en-US" sz="1200" dirty="0" err="1">
+                <a:latin typeface="Arial" panose="020B0604020202020204" pitchFamily="34" charset="0"/>
+                <a:cs typeface="Arial" panose="020B0604020202020204" pitchFamily="34" charset="0"/>
+              </a:rPr>
+              <a:t>modos</a:t>
+            </a:r>
+            <a:r>
+              <a:rPr lang="en-US" sz="1200" dirty="0">
+                <a:latin typeface="Arial" panose="020B0604020202020204" pitchFamily="34" charset="0"/>
+                <a:cs typeface="Arial" panose="020B0604020202020204" pitchFamily="34" charset="0"/>
+              </a:rPr>
+              <a:t> </a:t>
+            </a:r>
+            <a:r>
+              <a:rPr lang="en-US" sz="1200" dirty="0" err="1">
+                <a:latin typeface="Arial" panose="020B0604020202020204" pitchFamily="34" charset="0"/>
+                <a:cs typeface="Arial" panose="020B0604020202020204" pitchFamily="34" charset="0"/>
+              </a:rPr>
+              <a:t>que</a:t>
+            </a:r>
+            <a:r>
+              <a:rPr lang="en-US" sz="1200" dirty="0">
+                <a:latin typeface="Arial" panose="020B0604020202020204" pitchFamily="34" charset="0"/>
+                <a:cs typeface="Arial" panose="020B0604020202020204" pitchFamily="34" charset="0"/>
+              </a:rPr>
+              <a:t> </a:t>
+            </a:r>
+            <a:r>
+              <a:rPr lang="en-US" sz="1200" dirty="0" err="1">
+                <a:latin typeface="Arial" panose="020B0604020202020204" pitchFamily="34" charset="0"/>
+                <a:cs typeface="Arial" panose="020B0604020202020204" pitchFamily="34" charset="0"/>
+              </a:rPr>
+              <a:t>puede</a:t>
+            </a:r>
+            <a:r>
+              <a:rPr lang="en-US" sz="1200" dirty="0">
+                <a:latin typeface="Arial" panose="020B0604020202020204" pitchFamily="34" charset="0"/>
+                <a:cs typeface="Arial" panose="020B0604020202020204" pitchFamily="34" charset="0"/>
+              </a:rPr>
+              <a:t> </a:t>
+            </a:r>
+            <a:r>
+              <a:rPr lang="en-US" sz="1200" dirty="0" err="1">
+                <a:latin typeface="Arial" panose="020B0604020202020204" pitchFamily="34" charset="0"/>
+                <a:cs typeface="Arial" panose="020B0604020202020204" pitchFamily="34" charset="0"/>
+              </a:rPr>
+              <a:t>contener</a:t>
+            </a:r>
+            <a:r>
+              <a:rPr lang="en-US" sz="1200" dirty="0">
+                <a:latin typeface="Arial" panose="020B0604020202020204" pitchFamily="34" charset="0"/>
+                <a:cs typeface="Arial" panose="020B0604020202020204" pitchFamily="34" charset="0"/>
+              </a:rPr>
+              <a:t>. De </a:t>
+            </a:r>
+            <a:r>
+              <a:rPr lang="en-US" sz="1200" dirty="0" err="1">
+                <a:latin typeface="Arial" panose="020B0604020202020204" pitchFamily="34" charset="0"/>
+                <a:cs typeface="Arial" panose="020B0604020202020204" pitchFamily="34" charset="0"/>
+              </a:rPr>
+              <a:t>hecho</a:t>
+            </a:r>
+            <a:r>
+              <a:rPr lang="en-US" sz="1200" dirty="0">
+                <a:latin typeface="Arial" panose="020B0604020202020204" pitchFamily="34" charset="0"/>
+                <a:cs typeface="Arial" panose="020B0604020202020204" pitchFamily="34" charset="0"/>
+              </a:rPr>
+              <a:t> </a:t>
+            </a:r>
+            <a:r>
+              <a:rPr lang="en-US" sz="1200" dirty="0" err="1">
+                <a:latin typeface="Arial" panose="020B0604020202020204" pitchFamily="34" charset="0"/>
+                <a:cs typeface="Arial" panose="020B0604020202020204" pitchFamily="34" charset="0"/>
+              </a:rPr>
+              <a:t>en</a:t>
+            </a:r>
+            <a:r>
+              <a:rPr lang="en-US" sz="1200" dirty="0">
+                <a:latin typeface="Arial" panose="020B0604020202020204" pitchFamily="34" charset="0"/>
+                <a:cs typeface="Arial" panose="020B0604020202020204" pitchFamily="34" charset="0"/>
+              </a:rPr>
+              <a:t> la </a:t>
+            </a:r>
+            <a:r>
+              <a:rPr lang="en-US" sz="1200" dirty="0" err="1">
+                <a:latin typeface="Arial" panose="020B0604020202020204" pitchFamily="34" charset="0"/>
+                <a:cs typeface="Arial" panose="020B0604020202020204" pitchFamily="34" charset="0"/>
+              </a:rPr>
+              <a:t>siguiente</a:t>
+            </a:r>
+            <a:r>
+              <a:rPr lang="en-US" sz="1200" dirty="0">
+                <a:latin typeface="Arial" panose="020B0604020202020204" pitchFamily="34" charset="0"/>
+                <a:cs typeface="Arial" panose="020B0604020202020204" pitchFamily="34" charset="0"/>
+              </a:rPr>
+              <a:t> </a:t>
+            </a:r>
+            <a:r>
+              <a:rPr lang="en-US" sz="1200" dirty="0" err="1">
+                <a:latin typeface="Arial" panose="020B0604020202020204" pitchFamily="34" charset="0"/>
+                <a:cs typeface="Arial" panose="020B0604020202020204" pitchFamily="34" charset="0"/>
+              </a:rPr>
+              <a:t>diapositiva</a:t>
+            </a:r>
+            <a:r>
+              <a:rPr lang="en-US" sz="1200" dirty="0">
+                <a:latin typeface="Arial" panose="020B0604020202020204" pitchFamily="34" charset="0"/>
+                <a:cs typeface="Arial" panose="020B0604020202020204" pitchFamily="34" charset="0"/>
+              </a:rPr>
+              <a:t>, se </a:t>
+            </a:r>
+            <a:r>
+              <a:rPr lang="en-US" sz="1200" dirty="0" err="1">
+                <a:latin typeface="Arial" panose="020B0604020202020204" pitchFamily="34" charset="0"/>
+                <a:cs typeface="Arial" panose="020B0604020202020204" pitchFamily="34" charset="0"/>
+              </a:rPr>
+              <a:t>muestra</a:t>
+            </a:r>
+            <a:r>
+              <a:rPr lang="en-US" sz="1200" dirty="0">
+                <a:latin typeface="Arial" panose="020B0604020202020204" pitchFamily="34" charset="0"/>
+                <a:cs typeface="Arial" panose="020B0604020202020204" pitchFamily="34" charset="0"/>
+              </a:rPr>
+              <a:t> la </a:t>
+            </a:r>
+            <a:r>
+              <a:rPr lang="en-US" sz="1200" dirty="0" err="1">
+                <a:latin typeface="Arial" panose="020B0604020202020204" pitchFamily="34" charset="0"/>
+                <a:cs typeface="Arial" panose="020B0604020202020204" pitchFamily="34" charset="0"/>
+              </a:rPr>
+              <a:t>cantidad</a:t>
+            </a:r>
+            <a:r>
+              <a:rPr lang="en-US" sz="1200" dirty="0">
+                <a:latin typeface="Arial" panose="020B0604020202020204" pitchFamily="34" charset="0"/>
+                <a:cs typeface="Arial" panose="020B0604020202020204" pitchFamily="34" charset="0"/>
+              </a:rPr>
+              <a:t> de </a:t>
+            </a:r>
+            <a:r>
+              <a:rPr lang="en-US" sz="1200" dirty="0" err="1">
+                <a:latin typeface="Arial" panose="020B0604020202020204" pitchFamily="34" charset="0"/>
+                <a:cs typeface="Arial" panose="020B0604020202020204" pitchFamily="34" charset="0"/>
+              </a:rPr>
+              <a:t>modos</a:t>
+            </a:r>
+            <a:r>
+              <a:rPr lang="en-US" sz="1200" dirty="0">
+                <a:latin typeface="Arial" panose="020B0604020202020204" pitchFamily="34" charset="0"/>
+                <a:cs typeface="Arial" panose="020B0604020202020204" pitchFamily="34" charset="0"/>
+              </a:rPr>
+              <a:t> </a:t>
+            </a:r>
+            <a:r>
+              <a:rPr lang="en-US" sz="1200" dirty="0" err="1">
+                <a:latin typeface="Arial" panose="020B0604020202020204" pitchFamily="34" charset="0"/>
+                <a:cs typeface="Arial" panose="020B0604020202020204" pitchFamily="34" charset="0"/>
+              </a:rPr>
+              <a:t>totales</a:t>
+            </a:r>
+            <a:r>
+              <a:rPr lang="en-US" sz="1200" dirty="0">
+                <a:latin typeface="Arial" panose="020B0604020202020204" pitchFamily="34" charset="0"/>
+                <a:cs typeface="Arial" panose="020B0604020202020204" pitchFamily="34" charset="0"/>
+              </a:rPr>
+              <a:t>, </a:t>
+            </a:r>
+            <a:r>
+              <a:rPr lang="en-US" sz="1200" dirty="0" err="1">
+                <a:latin typeface="Arial" panose="020B0604020202020204" pitchFamily="34" charset="0"/>
+                <a:cs typeface="Arial" panose="020B0604020202020204" pitchFamily="34" charset="0"/>
+              </a:rPr>
+              <a:t>que</a:t>
+            </a:r>
+            <a:r>
+              <a:rPr lang="en-US" sz="1200" dirty="0">
+                <a:latin typeface="Arial" panose="020B0604020202020204" pitchFamily="34" charset="0"/>
+                <a:cs typeface="Arial" panose="020B0604020202020204" pitchFamily="34" charset="0"/>
+              </a:rPr>
+              <a:t> son </a:t>
+            </a:r>
+            <a:r>
+              <a:rPr lang="en-US" sz="1200" dirty="0" err="1">
+                <a:latin typeface="Arial" panose="020B0604020202020204" pitchFamily="34" charset="0"/>
+                <a:cs typeface="Arial" panose="020B0604020202020204" pitchFamily="34" charset="0"/>
+              </a:rPr>
+              <a:t>todos</a:t>
+            </a:r>
+            <a:r>
+              <a:rPr lang="en-US" sz="1200" dirty="0">
+                <a:latin typeface="Arial" panose="020B0604020202020204" pitchFamily="34" charset="0"/>
+                <a:cs typeface="Arial" panose="020B0604020202020204" pitchFamily="34" charset="0"/>
+              </a:rPr>
+              <a:t> </a:t>
+            </a:r>
+            <a:r>
+              <a:rPr lang="en-US" sz="1200" dirty="0" err="1">
+                <a:latin typeface="Arial" panose="020B0604020202020204" pitchFamily="34" charset="0"/>
+                <a:cs typeface="Arial" panose="020B0604020202020204" pitchFamily="34" charset="0"/>
+              </a:rPr>
+              <a:t>aquellos</a:t>
+            </a:r>
+            <a:r>
+              <a:rPr lang="en-US" sz="1200" dirty="0">
+                <a:latin typeface="Arial" panose="020B0604020202020204" pitchFamily="34" charset="0"/>
+                <a:cs typeface="Arial" panose="020B0604020202020204" pitchFamily="34" charset="0"/>
+              </a:rPr>
+              <a:t> </a:t>
+            </a:r>
+            <a:r>
+              <a:rPr lang="en-US" sz="1200" dirty="0" err="1">
+                <a:latin typeface="Arial" panose="020B0604020202020204" pitchFamily="34" charset="0"/>
+                <a:cs typeface="Arial" panose="020B0604020202020204" pitchFamily="34" charset="0"/>
+              </a:rPr>
+              <a:t>que</a:t>
+            </a:r>
+            <a:r>
+              <a:rPr lang="en-US" sz="1200" dirty="0">
+                <a:latin typeface="Arial" panose="020B0604020202020204" pitchFamily="34" charset="0"/>
+                <a:cs typeface="Arial" panose="020B0604020202020204" pitchFamily="34" charset="0"/>
+              </a:rPr>
+              <a:t> </a:t>
+            </a:r>
+            <a:r>
+              <a:rPr lang="en-US" sz="1200" dirty="0" err="1">
+                <a:latin typeface="Arial" panose="020B0604020202020204" pitchFamily="34" charset="0"/>
+                <a:cs typeface="Arial" panose="020B0604020202020204" pitchFamily="34" charset="0"/>
+              </a:rPr>
+              <a:t>tengan</a:t>
+            </a:r>
+            <a:r>
+              <a:rPr lang="en-US" sz="1200" dirty="0">
+                <a:latin typeface="Arial" panose="020B0604020202020204" pitchFamily="34" charset="0"/>
+                <a:cs typeface="Arial" panose="020B0604020202020204" pitchFamily="34" charset="0"/>
+              </a:rPr>
+              <a:t> un </a:t>
+            </a:r>
+            <a:r>
+              <a:rPr lang="en-US" sz="1200" dirty="0" err="1">
+                <a:latin typeface="Arial" panose="020B0604020202020204" pitchFamily="34" charset="0"/>
+                <a:cs typeface="Arial" panose="020B0604020202020204" pitchFamily="34" charset="0"/>
+              </a:rPr>
+              <a:t>índice</a:t>
+            </a:r>
+            <a:r>
+              <a:rPr lang="en-US" sz="1200" dirty="0">
+                <a:latin typeface="Arial" panose="020B0604020202020204" pitchFamily="34" charset="0"/>
+                <a:cs typeface="Arial" panose="020B0604020202020204" pitchFamily="34" charset="0"/>
+              </a:rPr>
+              <a:t> </a:t>
+            </a:r>
+            <a:r>
+              <a:rPr lang="en-US" sz="1200" dirty="0" err="1">
+                <a:latin typeface="Arial" panose="020B0604020202020204" pitchFamily="34" charset="0"/>
+                <a:cs typeface="Arial" panose="020B0604020202020204" pitchFamily="34" charset="0"/>
+              </a:rPr>
+              <a:t>efectivo</a:t>
+            </a:r>
+            <a:r>
+              <a:rPr lang="en-US" sz="1200" dirty="0">
+                <a:latin typeface="Arial" panose="020B0604020202020204" pitchFamily="34" charset="0"/>
+                <a:cs typeface="Arial" panose="020B0604020202020204" pitchFamily="34" charset="0"/>
+              </a:rPr>
+              <a:t> </a:t>
+            </a:r>
+            <a:r>
+              <a:rPr lang="en-US" sz="1200" dirty="0" err="1">
+                <a:latin typeface="Arial" panose="020B0604020202020204" pitchFamily="34" charset="0"/>
+                <a:cs typeface="Arial" panose="020B0604020202020204" pitchFamily="34" charset="0"/>
+              </a:rPr>
+              <a:t>por</a:t>
+            </a:r>
+            <a:r>
+              <a:rPr lang="en-US" sz="1200" dirty="0">
+                <a:latin typeface="Arial" panose="020B0604020202020204" pitchFamily="34" charset="0"/>
+                <a:cs typeface="Arial" panose="020B0604020202020204" pitchFamily="34" charset="0"/>
+              </a:rPr>
+              <a:t> </a:t>
+            </a:r>
+            <a:r>
+              <a:rPr lang="en-US" sz="1200" dirty="0" err="1">
+                <a:latin typeface="Arial" panose="020B0604020202020204" pitchFamily="34" charset="0"/>
+                <a:cs typeface="Arial" panose="020B0604020202020204" pitchFamily="34" charset="0"/>
+              </a:rPr>
+              <a:t>encima</a:t>
+            </a:r>
+            <a:r>
+              <a:rPr lang="en-US" sz="1200" dirty="0">
+                <a:latin typeface="Arial" panose="020B0604020202020204" pitchFamily="34" charset="0"/>
+                <a:cs typeface="Arial" panose="020B0604020202020204" pitchFamily="34" charset="0"/>
+              </a:rPr>
+              <a:t> del cladding, </a:t>
+            </a:r>
+            <a:r>
+              <a:rPr lang="en-US" sz="1200" dirty="0" err="1">
+                <a:latin typeface="Arial" panose="020B0604020202020204" pitchFamily="34" charset="0"/>
+                <a:cs typeface="Arial" panose="020B0604020202020204" pitchFamily="34" charset="0"/>
+              </a:rPr>
+              <a:t>que</a:t>
+            </a:r>
+            <a:r>
+              <a:rPr lang="en-US" sz="1200" dirty="0">
+                <a:latin typeface="Arial" panose="020B0604020202020204" pitchFamily="34" charset="0"/>
+                <a:cs typeface="Arial" panose="020B0604020202020204" pitchFamily="34" charset="0"/>
+              </a:rPr>
+              <a:t> es de </a:t>
+            </a:r>
+            <a:r>
+              <a:rPr lang="en-US" sz="1200" dirty="0" err="1">
+                <a:latin typeface="Arial" panose="020B0604020202020204" pitchFamily="34" charset="0"/>
+                <a:cs typeface="Arial" panose="020B0604020202020204" pitchFamily="34" charset="0"/>
+              </a:rPr>
+              <a:t>alrededor</a:t>
+            </a:r>
+            <a:r>
+              <a:rPr lang="en-US" sz="1200" dirty="0">
+                <a:latin typeface="Arial" panose="020B0604020202020204" pitchFamily="34" charset="0"/>
+                <a:cs typeface="Arial" panose="020B0604020202020204" pitchFamily="34" charset="0"/>
+              </a:rPr>
+              <a:t> de 1.44.</a:t>
+            </a:r>
+          </a:p>
+          <a:p>
+            <a:pPr algn="just"/>
+            <a:endParaRPr lang="en-US" sz="1200" dirty="0">
+              <a:latin typeface="Arial" panose="020B0604020202020204" pitchFamily="34" charset="0"/>
+              <a:cs typeface="Arial" panose="020B0604020202020204" pitchFamily="34" charset="0"/>
+            </a:endParaRPr>
+          </a:p>
+          <a:p>
+            <a:pPr algn="just"/>
+            <a:endParaRPr lang="en-US" sz="1200" dirty="0">
+              <a:latin typeface="Arial" panose="020B0604020202020204" pitchFamily="34" charset="0"/>
+              <a:cs typeface="Arial" panose="020B0604020202020204" pitchFamily="34" charset="0"/>
+            </a:endParaRPr>
+          </a:p>
+          <a:p>
+            <a:pPr algn="just"/>
+            <a:endParaRPr lang="en-US" sz="1200" dirty="0">
+              <a:latin typeface="Arial" panose="020B0604020202020204" pitchFamily="34" charset="0"/>
+              <a:cs typeface="Arial" panose="020B0604020202020204" pitchFamily="34" charset="0"/>
+            </a:endParaRPr>
+          </a:p>
+          <a:p>
+            <a:pPr algn="just"/>
+            <a:endParaRPr lang="en-US" sz="1200" dirty="0">
+              <a:latin typeface="Arial" panose="020B0604020202020204" pitchFamily="34" charset="0"/>
+              <a:cs typeface="Arial" panose="020B0604020202020204" pitchFamily="34" charset="0"/>
+            </a:endParaRPr>
+          </a:p>
+          <a:p>
+            <a:pPr algn="just"/>
+            <a:endParaRPr lang="en-US" sz="1200" dirty="0">
+              <a:latin typeface="Arial" panose="020B0604020202020204" pitchFamily="34" charset="0"/>
+              <a:cs typeface="Arial" panose="020B0604020202020204" pitchFamily="34" charset="0"/>
+            </a:endParaRPr>
+          </a:p>
+          <a:p>
+            <a:pPr algn="just"/>
+            <a:endParaRPr lang="en-US" sz="1200" dirty="0">
+              <a:latin typeface="Arial" panose="020B0604020202020204" pitchFamily="34" charset="0"/>
+              <a:cs typeface="Arial" panose="020B0604020202020204" pitchFamily="34" charset="0"/>
+            </a:endParaRPr>
+          </a:p>
+        </p:txBody>
+      </p:sp>
+      <p:pic>
+        <p:nvPicPr>
+          <p:cNvPr id="6" name="Imagen 5" descr="Interfaz de usuario gráfica, Aplicación, Word&#10;&#10;El contenido generado por IA puede ser incorrecto.">
+            <a:extLst>
+              <a:ext uri="{FF2B5EF4-FFF2-40B4-BE49-F238E27FC236}">
+                <a16:creationId xmlns:a16="http://schemas.microsoft.com/office/drawing/2014/main" id="{57882ACE-8FAC-5F67-8EA3-8A4E74CA006F}"/>
+              </a:ext>
+            </a:extLst>
+          </p:cNvPr>
+          <p:cNvPicPr>
+            <a:picLocks noChangeAspect="1"/>
+          </p:cNvPicPr>
+          <p:nvPr/>
+        </p:nvPicPr>
+        <p:blipFill>
+          <a:blip r:embed="rId5"/>
+          <a:stretch>
+            <a:fillRect/>
+          </a:stretch>
+        </p:blipFill>
+        <p:spPr>
+          <a:xfrm>
+            <a:off x="608012" y="1009948"/>
+            <a:ext cx="3119567" cy="2266652"/>
+          </a:xfrm>
+          <a:prstGeom prst="rect">
+            <a:avLst/>
+          </a:prstGeom>
+        </p:spPr>
+      </p:pic>
+      <p:pic>
+        <p:nvPicPr>
+          <p:cNvPr id="8" name="Imagen 7" descr="Interfaz de usuario gráfica, Word&#10;&#10;El contenido generado por IA puede ser incorrecto.">
+            <a:extLst>
+              <a:ext uri="{FF2B5EF4-FFF2-40B4-BE49-F238E27FC236}">
+                <a16:creationId xmlns:a16="http://schemas.microsoft.com/office/drawing/2014/main" id="{E063E233-7685-49A7-56E8-9296DAA8210D}"/>
+              </a:ext>
+            </a:extLst>
+          </p:cNvPr>
+          <p:cNvPicPr>
+            <a:picLocks noChangeAspect="1"/>
+          </p:cNvPicPr>
+          <p:nvPr/>
+        </p:nvPicPr>
+        <p:blipFill>
+          <a:blip r:embed="rId6"/>
+          <a:stretch>
+            <a:fillRect/>
+          </a:stretch>
+        </p:blipFill>
+        <p:spPr>
+          <a:xfrm>
+            <a:off x="4343400" y="1073407"/>
+            <a:ext cx="3121505" cy="2203193"/>
+          </a:xfrm>
+          <a:prstGeom prst="rect">
+            <a:avLst/>
+          </a:prstGeom>
+        </p:spPr>
+      </p:pic>
+      <p:pic>
+        <p:nvPicPr>
+          <p:cNvPr id="10" name="Imagen 9" descr="Interfaz de usuario gráfica, Aplicación&#10;&#10;El contenido generado por IA puede ser incorrecto.">
+            <a:extLst>
+              <a:ext uri="{FF2B5EF4-FFF2-40B4-BE49-F238E27FC236}">
+                <a16:creationId xmlns:a16="http://schemas.microsoft.com/office/drawing/2014/main" id="{BC844408-22BF-A0B3-5CC7-1AE012D3C6A4}"/>
+              </a:ext>
+            </a:extLst>
+          </p:cNvPr>
+          <p:cNvPicPr>
+            <a:picLocks noChangeAspect="1"/>
+          </p:cNvPicPr>
+          <p:nvPr/>
+        </p:nvPicPr>
+        <p:blipFill>
+          <a:blip r:embed="rId7"/>
+          <a:stretch>
+            <a:fillRect/>
+          </a:stretch>
+        </p:blipFill>
+        <p:spPr>
+          <a:xfrm>
+            <a:off x="7954927" y="1024007"/>
+            <a:ext cx="3213038" cy="2218526"/>
+          </a:xfrm>
+          <a:prstGeom prst="rect">
+            <a:avLst/>
+          </a:prstGeom>
+        </p:spPr>
+      </p:pic>
+      <p:pic>
+        <p:nvPicPr>
+          <p:cNvPr id="12" name="Imagen 11" descr="Texto&#10;&#10;El contenido generado por IA puede ser incorrecto.">
+            <a:extLst>
+              <a:ext uri="{FF2B5EF4-FFF2-40B4-BE49-F238E27FC236}">
+                <a16:creationId xmlns:a16="http://schemas.microsoft.com/office/drawing/2014/main" id="{89DA6B2C-0C0A-7D6B-2553-BC460674EA66}"/>
+              </a:ext>
+            </a:extLst>
+          </p:cNvPr>
+          <p:cNvPicPr>
+            <a:picLocks noChangeAspect="1"/>
+          </p:cNvPicPr>
+          <p:nvPr/>
+        </p:nvPicPr>
+        <p:blipFill>
+          <a:blip r:embed="rId8"/>
+          <a:stretch>
+            <a:fillRect/>
+          </a:stretch>
+        </p:blipFill>
+        <p:spPr>
+          <a:xfrm>
+            <a:off x="633412" y="3328120"/>
+            <a:ext cx="8202170" cy="1257475"/>
+          </a:xfrm>
+          <a:prstGeom prst="rect">
+            <a:avLst/>
+          </a:prstGeom>
+        </p:spPr>
+      </p:pic>
+    </p:spTree>
+    <p:extLst>
+      <p:ext uri="{BB962C8B-B14F-4D97-AF65-F5344CB8AC3E}">
+        <p14:creationId xmlns:p14="http://schemas.microsoft.com/office/powerpoint/2010/main" val="884340404"/>
+      </p:ext>
+    </p:extLst>
+  </p:cSld>
+  <p:clrMapOvr>
+    <a:masterClrMapping/>
+  </p:clrMapOvr>
+</p:sld>
+</file>
+
+<file path=ppt/slides/slide12.xml><?xml version="1.0" encoding="utf-8"?>
+<p:sld xmlns:a="http://schemas.openxmlformats.org/drawingml/2006/main" xmlns:r="http://schemas.openxmlformats.org/officeDocument/2006/relationships" xmlns:p="http://schemas.openxmlformats.org/presentationml/2006/main">
+  <p:cSld>
+    <p:spTree>
+      <p:nvGrpSpPr>
+        <p:cNvPr id="1" name="">
+          <a:extLst>
+            <a:ext uri="{FF2B5EF4-FFF2-40B4-BE49-F238E27FC236}">
+              <a16:creationId xmlns:a16="http://schemas.microsoft.com/office/drawing/2014/main" id="{9971F110-022E-068B-CC43-2207276847EF}"/>
+            </a:ext>
+          </a:extLst>
+        </p:cNvPr>
+        <p:cNvGrpSpPr/>
+        <p:nvPr/>
+      </p:nvGrpSpPr>
+      <p:grpSpPr>
+        <a:xfrm>
+          <a:off x="0" y="0"/>
+          <a:ext cx="0" cy="0"/>
+          <a:chOff x="0" y="0"/>
+          <a:chExt cx="0" cy="0"/>
+        </a:xfrm>
+      </p:grpSpPr>
+      <p:sp>
+        <p:nvSpPr>
+          <p:cNvPr id="16" name="object 16">
+            <a:extLst>
+              <a:ext uri="{FF2B5EF4-FFF2-40B4-BE49-F238E27FC236}">
+                <a16:creationId xmlns:a16="http://schemas.microsoft.com/office/drawing/2014/main" id="{E8D2ECC0-C9FD-7E56-6516-B614CB202787}"/>
+              </a:ext>
+            </a:extLst>
+          </p:cNvPr>
+          <p:cNvSpPr txBox="1">
+            <a:spLocks noGrp="1"/>
+          </p:cNvSpPr>
+          <p:nvPr>
+            <p:ph type="title"/>
+          </p:nvPr>
+        </p:nvSpPr>
+        <p:spPr>
+          <a:xfrm>
+            <a:off x="685800" y="408883"/>
+            <a:ext cx="10994410" cy="397545"/>
+          </a:xfrm>
+          <a:prstGeom prst="rect">
+            <a:avLst/>
+          </a:prstGeom>
+        </p:spPr>
+        <p:txBody>
+          <a:bodyPr vert="horz" wrap="square" lIns="0" tIns="12700" rIns="0" bIns="0" rtlCol="0">
+            <a:spAutoFit/>
+          </a:bodyPr>
+          <a:lstStyle/>
+          <a:p>
+            <a:pPr marL="12700">
+              <a:lnSpc>
+                <a:spcPct val="100000"/>
+              </a:lnSpc>
+              <a:spcBef>
+                <a:spcPts val="100"/>
+              </a:spcBef>
+            </a:pPr>
+            <a:r>
+              <a:rPr lang="en-US" sz="2500" dirty="0"/>
+              <a:t>Learning outcome #2 – Multimode Interference (MMI) Coupler cross-section</a:t>
+            </a:r>
+            <a:endParaRPr lang="en-US" sz="2500" b="0" dirty="0">
+              <a:latin typeface="+mj-lt"/>
+              <a:cs typeface="Lucida Sans"/>
+            </a:endParaRPr>
+          </a:p>
+        </p:txBody>
+      </p:sp>
+      <p:pic>
+        <p:nvPicPr>
+          <p:cNvPr id="83" name="Gráfico 82">
+            <a:extLst>
+              <a:ext uri="{FF2B5EF4-FFF2-40B4-BE49-F238E27FC236}">
+                <a16:creationId xmlns:a16="http://schemas.microsoft.com/office/drawing/2014/main" id="{90FAF690-4D4D-1D71-20D0-E1B4C4AC1A74}"/>
+              </a:ext>
+            </a:extLst>
+          </p:cNvPr>
+          <p:cNvPicPr>
+            <a:picLocks noChangeAspect="1"/>
+          </p:cNvPicPr>
+          <p:nvPr/>
+        </p:nvPicPr>
+        <p:blipFill>
+          <a:blip r:embed="rId3">
+            <a:extLst>
+              <a:ext uri="{96DAC541-7B7A-43D3-8B79-37D633B846F1}">
+                <asvg:svgBlip xmlns:asvg="http://schemas.microsoft.com/office/drawing/2016/SVG/main" r:embed="rId4"/>
+              </a:ext>
+            </a:extLst>
+          </a:blip>
+          <a:stretch>
+            <a:fillRect/>
+          </a:stretch>
+        </p:blipFill>
+        <p:spPr>
+          <a:xfrm>
+            <a:off x="5045006" y="6356057"/>
+            <a:ext cx="6409575" cy="363174"/>
+          </a:xfrm>
+          <a:prstGeom prst="rect">
+            <a:avLst/>
+          </a:prstGeom>
+        </p:spPr>
+      </p:pic>
+      <p:sp>
+        <p:nvSpPr>
+          <p:cNvPr id="84" name="Marcador de número de diapositiva 83">
+            <a:extLst>
+              <a:ext uri="{FF2B5EF4-FFF2-40B4-BE49-F238E27FC236}">
+                <a16:creationId xmlns:a16="http://schemas.microsoft.com/office/drawing/2014/main" id="{B97C2AD5-3150-0B0D-AA15-D5211B49F395}"/>
+              </a:ext>
+            </a:extLst>
+          </p:cNvPr>
+          <p:cNvSpPr>
+            <a:spLocks noGrp="1"/>
+          </p:cNvSpPr>
+          <p:nvPr>
+            <p:ph type="sldNum" sz="quarter" idx="7"/>
+          </p:nvPr>
+        </p:nvSpPr>
+        <p:spPr/>
+        <p:txBody>
+          <a:bodyPr/>
+          <a:lstStyle/>
+          <a:p>
+            <a:fld id="{B6F15528-21DE-4FAA-801E-634DDDAF4B2B}" type="slidenum">
+              <a:rPr lang="es-ES" smtClean="0"/>
+              <a:t>12</a:t>
+            </a:fld>
+            <a:endParaRPr lang="es-ES"/>
+          </a:p>
+        </p:txBody>
+      </p:sp>
+      <p:sp>
+        <p:nvSpPr>
+          <p:cNvPr id="3" name="Marcador de pie de página 2">
+            <a:extLst>
+              <a:ext uri="{FF2B5EF4-FFF2-40B4-BE49-F238E27FC236}">
+                <a16:creationId xmlns:a16="http://schemas.microsoft.com/office/drawing/2014/main" id="{A9888B22-3101-015F-9E7E-4B4B029D67C4}"/>
+              </a:ext>
+            </a:extLst>
+          </p:cNvPr>
+          <p:cNvSpPr>
+            <a:spLocks noGrp="1"/>
+          </p:cNvSpPr>
+          <p:nvPr>
+            <p:ph type="ftr" sz="quarter" idx="5"/>
+          </p:nvPr>
+        </p:nvSpPr>
+        <p:spPr/>
+        <p:txBody>
+          <a:bodyPr/>
+          <a:lstStyle/>
+          <a:p>
+            <a:pPr marL="12700">
+              <a:spcBef>
+                <a:spcPts val="15"/>
+              </a:spcBef>
+            </a:pPr>
+            <a:r>
+              <a:rPr lang="es-ES" spc="-5"/>
+              <a:t>LAB 0.2. COUPLERS</a:t>
+            </a:r>
+            <a:endParaRPr lang="es-ES" spc="-5" dirty="0"/>
+          </a:p>
+        </p:txBody>
+      </p:sp>
+      <p:sp>
+        <p:nvSpPr>
+          <p:cNvPr id="4" name="Marcador de texto 2">
+            <a:extLst>
+              <a:ext uri="{FF2B5EF4-FFF2-40B4-BE49-F238E27FC236}">
+                <a16:creationId xmlns:a16="http://schemas.microsoft.com/office/drawing/2014/main" id="{4DFC99FA-7158-789D-3A10-1BF8F8C58668}"/>
+              </a:ext>
+            </a:extLst>
+          </p:cNvPr>
+          <p:cNvSpPr txBox="1">
+            <a:spLocks/>
+          </p:cNvSpPr>
+          <p:nvPr/>
+        </p:nvSpPr>
+        <p:spPr>
+          <a:xfrm>
+            <a:off x="608012" y="1295400"/>
+            <a:ext cx="11048999" cy="4958137"/>
+          </a:xfrm>
+          <a:prstGeom prst="rect">
+            <a:avLst/>
+          </a:prstGeom>
+        </p:spPr>
+        <p:txBody>
+          <a:bodyPr>
+            <a:normAutofit/>
+          </a:bodyPr>
+          <a:lstStyle>
+            <a:lvl1pPr marL="0">
+              <a:defRPr>
+                <a:latin typeface="+mn-lt"/>
+                <a:ea typeface="+mn-ea"/>
+                <a:cs typeface="+mn-cs"/>
+              </a:defRPr>
+            </a:lvl1pPr>
+            <a:lvl2pPr marL="457200">
+              <a:defRPr>
+                <a:latin typeface="+mn-lt"/>
+                <a:ea typeface="+mn-ea"/>
+                <a:cs typeface="+mn-cs"/>
+              </a:defRPr>
+            </a:lvl2pPr>
+            <a:lvl3pPr marL="914400">
+              <a:defRPr>
+                <a:latin typeface="+mn-lt"/>
+                <a:ea typeface="+mn-ea"/>
+                <a:cs typeface="+mn-cs"/>
+              </a:defRPr>
+            </a:lvl3pPr>
+            <a:lvl4pPr marL="1371600">
+              <a:defRPr>
+                <a:latin typeface="+mn-lt"/>
+                <a:ea typeface="+mn-ea"/>
+                <a:cs typeface="+mn-cs"/>
+              </a:defRPr>
+            </a:lvl4pPr>
+            <a:lvl5pPr marL="1828800">
+              <a:defRPr>
+                <a:latin typeface="+mn-lt"/>
+                <a:ea typeface="+mn-ea"/>
+                <a:cs typeface="+mn-cs"/>
+              </a:defRPr>
+            </a:lvl5pPr>
+            <a:lvl6pPr marL="2286000">
+              <a:defRPr>
+                <a:latin typeface="+mn-lt"/>
+                <a:ea typeface="+mn-ea"/>
+                <a:cs typeface="+mn-cs"/>
+              </a:defRPr>
+            </a:lvl6pPr>
+            <a:lvl7pPr marL="2743200">
+              <a:defRPr>
+                <a:latin typeface="+mn-lt"/>
+                <a:ea typeface="+mn-ea"/>
+                <a:cs typeface="+mn-cs"/>
+              </a:defRPr>
+            </a:lvl7pPr>
+            <a:lvl8pPr marL="3200400">
+              <a:defRPr>
+                <a:latin typeface="+mn-lt"/>
+                <a:ea typeface="+mn-ea"/>
+                <a:cs typeface="+mn-cs"/>
+              </a:defRPr>
+            </a:lvl8pPr>
+            <a:lvl9pPr marL="3657600">
+              <a:defRPr>
+                <a:latin typeface="+mn-lt"/>
+                <a:ea typeface="+mn-ea"/>
+                <a:cs typeface="+mn-cs"/>
+              </a:defRPr>
+            </a:lvl9pPr>
+          </a:lstStyle>
+          <a:p>
+            <a:pPr algn="just"/>
+            <a:endParaRPr lang="en-US" sz="2000" b="1" i="1" u="sng" dirty="0"/>
+          </a:p>
+          <a:p>
+            <a:pPr algn="just"/>
+            <a:endParaRPr lang="en-US" sz="2000" kern="0" dirty="0">
+              <a:solidFill>
+                <a:sysClr val="windowText" lastClr="000000"/>
+              </a:solidFill>
+            </a:endParaRPr>
+          </a:p>
+        </p:txBody>
+      </p:sp>
+      <p:sp>
+        <p:nvSpPr>
+          <p:cNvPr id="2" name="CuadroTexto 1">
+            <a:extLst>
+              <a:ext uri="{FF2B5EF4-FFF2-40B4-BE49-F238E27FC236}">
+                <a16:creationId xmlns:a16="http://schemas.microsoft.com/office/drawing/2014/main" id="{29AE18A2-248D-0741-00E1-25B713E809F2}"/>
+              </a:ext>
+            </a:extLst>
+          </p:cNvPr>
+          <p:cNvSpPr txBox="1"/>
+          <p:nvPr/>
+        </p:nvSpPr>
+        <p:spPr>
+          <a:xfrm>
+            <a:off x="608012" y="4903378"/>
+            <a:ext cx="11199971" cy="1384995"/>
+          </a:xfrm>
+          <a:prstGeom prst="rect">
+            <a:avLst/>
+          </a:prstGeom>
+          <a:solidFill>
+            <a:schemeClr val="bg1">
+              <a:lumMod val="95000"/>
+            </a:schemeClr>
+          </a:solidFill>
+          <a:ln w="28575">
+            <a:solidFill>
+              <a:srgbClr val="E0700D"/>
+            </a:solidFill>
+          </a:ln>
+        </p:spPr>
+        <p:txBody>
+          <a:bodyPr wrap="square" rtlCol="0">
+            <a:spAutoFit/>
+          </a:bodyPr>
+          <a:lstStyle/>
+          <a:p>
+            <a:pPr algn="just"/>
+            <a:r>
+              <a:rPr lang="en-US" sz="1200" dirty="0">
+                <a:latin typeface="Arial" panose="020B0604020202020204" pitchFamily="34" charset="0"/>
+                <a:cs typeface="Arial" panose="020B0604020202020204" pitchFamily="34" charset="0"/>
+              </a:rPr>
+              <a:t>He </a:t>
+            </a:r>
+            <a:r>
+              <a:rPr lang="en-US" sz="1200" dirty="0" err="1">
+                <a:latin typeface="Arial" panose="020B0604020202020204" pitchFamily="34" charset="0"/>
+                <a:cs typeface="Arial" panose="020B0604020202020204" pitchFamily="34" charset="0"/>
+              </a:rPr>
+              <a:t>simulado</a:t>
+            </a:r>
+            <a:r>
+              <a:rPr lang="en-US" sz="1200" dirty="0">
+                <a:latin typeface="Arial" panose="020B0604020202020204" pitchFamily="34" charset="0"/>
+                <a:cs typeface="Arial" panose="020B0604020202020204" pitchFamily="34" charset="0"/>
+              </a:rPr>
+              <a:t> 35 </a:t>
+            </a:r>
+            <a:r>
+              <a:rPr lang="en-US" sz="1200" dirty="0" err="1">
+                <a:latin typeface="Arial" panose="020B0604020202020204" pitchFamily="34" charset="0"/>
+                <a:cs typeface="Arial" panose="020B0604020202020204" pitchFamily="34" charset="0"/>
+              </a:rPr>
+              <a:t>modos</a:t>
+            </a:r>
+            <a:r>
+              <a:rPr lang="en-US" sz="1200" dirty="0">
+                <a:latin typeface="Arial" panose="020B0604020202020204" pitchFamily="34" charset="0"/>
+                <a:cs typeface="Arial" panose="020B0604020202020204" pitchFamily="34" charset="0"/>
+              </a:rPr>
+              <a:t>, y </a:t>
+            </a:r>
+            <a:r>
+              <a:rPr lang="en-US" sz="1200" dirty="0" err="1">
+                <a:latin typeface="Arial" panose="020B0604020202020204" pitchFamily="34" charset="0"/>
+                <a:cs typeface="Arial" panose="020B0604020202020204" pitchFamily="34" charset="0"/>
+              </a:rPr>
+              <a:t>vemos</a:t>
+            </a:r>
+            <a:r>
+              <a:rPr lang="en-US" sz="1200" dirty="0">
+                <a:latin typeface="Arial" panose="020B0604020202020204" pitchFamily="34" charset="0"/>
+                <a:cs typeface="Arial" panose="020B0604020202020204" pitchFamily="34" charset="0"/>
+              </a:rPr>
+              <a:t> </a:t>
+            </a:r>
+            <a:r>
+              <a:rPr lang="en-US" sz="1200" dirty="0" err="1">
+                <a:latin typeface="Arial" panose="020B0604020202020204" pitchFamily="34" charset="0"/>
+                <a:cs typeface="Arial" panose="020B0604020202020204" pitchFamily="34" charset="0"/>
+              </a:rPr>
+              <a:t>que</a:t>
+            </a:r>
+            <a:r>
+              <a:rPr lang="en-US" sz="1200" dirty="0">
+                <a:latin typeface="Arial" panose="020B0604020202020204" pitchFamily="34" charset="0"/>
+                <a:cs typeface="Arial" panose="020B0604020202020204" pitchFamily="34" charset="0"/>
+              </a:rPr>
+              <a:t> </a:t>
+            </a:r>
+            <a:r>
+              <a:rPr lang="en-US" sz="1200" dirty="0" err="1">
+                <a:latin typeface="Arial" panose="020B0604020202020204" pitchFamily="34" charset="0"/>
+                <a:cs typeface="Arial" panose="020B0604020202020204" pitchFamily="34" charset="0"/>
+              </a:rPr>
+              <a:t>el</a:t>
+            </a:r>
+            <a:r>
+              <a:rPr lang="en-US" sz="1200" dirty="0">
+                <a:latin typeface="Arial" panose="020B0604020202020204" pitchFamily="34" charset="0"/>
+                <a:cs typeface="Arial" panose="020B0604020202020204" pitchFamily="34" charset="0"/>
+              </a:rPr>
+              <a:t> </a:t>
+            </a:r>
+            <a:r>
+              <a:rPr lang="en-US" sz="1200" dirty="0" err="1">
+                <a:latin typeface="Arial" panose="020B0604020202020204" pitchFamily="34" charset="0"/>
+                <a:cs typeface="Arial" panose="020B0604020202020204" pitchFamily="34" charset="0"/>
+              </a:rPr>
+              <a:t>último</a:t>
+            </a:r>
+            <a:r>
+              <a:rPr lang="en-US" sz="1200" dirty="0">
+                <a:latin typeface="Arial" panose="020B0604020202020204" pitchFamily="34" charset="0"/>
+                <a:cs typeface="Arial" panose="020B0604020202020204" pitchFamily="34" charset="0"/>
+              </a:rPr>
+              <a:t> </a:t>
+            </a:r>
+            <a:r>
+              <a:rPr lang="en-US" sz="1200" dirty="0" err="1">
+                <a:latin typeface="Arial" panose="020B0604020202020204" pitchFamily="34" charset="0"/>
+                <a:cs typeface="Arial" panose="020B0604020202020204" pitchFamily="34" charset="0"/>
+              </a:rPr>
+              <a:t>que</a:t>
+            </a:r>
+            <a:r>
+              <a:rPr lang="en-US" sz="1200" dirty="0">
+                <a:latin typeface="Arial" panose="020B0604020202020204" pitchFamily="34" charset="0"/>
+                <a:cs typeface="Arial" panose="020B0604020202020204" pitchFamily="34" charset="0"/>
+              </a:rPr>
+              <a:t> </a:t>
+            </a:r>
+            <a:r>
+              <a:rPr lang="en-US" sz="1200" dirty="0" err="1">
+                <a:latin typeface="Arial" panose="020B0604020202020204" pitchFamily="34" charset="0"/>
+                <a:cs typeface="Arial" panose="020B0604020202020204" pitchFamily="34" charset="0"/>
+              </a:rPr>
+              <a:t>tiene</a:t>
+            </a:r>
+            <a:r>
+              <a:rPr lang="en-US" sz="1200" dirty="0">
+                <a:latin typeface="Arial" panose="020B0604020202020204" pitchFamily="34" charset="0"/>
+                <a:cs typeface="Arial" panose="020B0604020202020204" pitchFamily="34" charset="0"/>
+              </a:rPr>
+              <a:t> un </a:t>
+            </a:r>
+            <a:r>
+              <a:rPr lang="en-US" sz="1200" dirty="0" err="1">
+                <a:latin typeface="Arial" panose="020B0604020202020204" pitchFamily="34" charset="0"/>
+                <a:cs typeface="Arial" panose="020B0604020202020204" pitchFamily="34" charset="0"/>
+              </a:rPr>
+              <a:t>indice</a:t>
+            </a:r>
+            <a:r>
+              <a:rPr lang="en-US" sz="1200" dirty="0">
+                <a:latin typeface="Arial" panose="020B0604020202020204" pitchFamily="34" charset="0"/>
+                <a:cs typeface="Arial" panose="020B0604020202020204" pitchFamily="34" charset="0"/>
+              </a:rPr>
+              <a:t> superior a 1.44 es </a:t>
+            </a:r>
+            <a:r>
+              <a:rPr lang="en-US" sz="1200" dirty="0" err="1">
+                <a:latin typeface="Arial" panose="020B0604020202020204" pitchFamily="34" charset="0"/>
+                <a:cs typeface="Arial" panose="020B0604020202020204" pitchFamily="34" charset="0"/>
+              </a:rPr>
+              <a:t>el</a:t>
+            </a:r>
+            <a:r>
+              <a:rPr lang="en-US" sz="1200" dirty="0">
+                <a:latin typeface="Arial" panose="020B0604020202020204" pitchFamily="34" charset="0"/>
+                <a:cs typeface="Arial" panose="020B0604020202020204" pitchFamily="34" charset="0"/>
+              </a:rPr>
+              <a:t> </a:t>
+            </a:r>
+            <a:r>
+              <a:rPr lang="en-US" sz="1200" dirty="0" err="1">
+                <a:latin typeface="Arial" panose="020B0604020202020204" pitchFamily="34" charset="0"/>
+                <a:cs typeface="Arial" panose="020B0604020202020204" pitchFamily="34" charset="0"/>
+              </a:rPr>
+              <a:t>señalado</a:t>
+            </a:r>
+            <a:r>
+              <a:rPr lang="en-US" sz="1200" dirty="0">
+                <a:latin typeface="Arial" panose="020B0604020202020204" pitchFamily="34" charset="0"/>
+                <a:cs typeface="Arial" panose="020B0604020202020204" pitchFamily="34" charset="0"/>
+              </a:rPr>
+              <a:t>. Por lo </a:t>
+            </a:r>
+            <a:r>
+              <a:rPr lang="en-US" sz="1200" dirty="0" err="1">
+                <a:latin typeface="Arial" panose="020B0604020202020204" pitchFamily="34" charset="0"/>
+                <a:cs typeface="Arial" panose="020B0604020202020204" pitchFamily="34" charset="0"/>
+              </a:rPr>
+              <a:t>que</a:t>
+            </a:r>
+            <a:r>
+              <a:rPr lang="en-US" sz="1200" dirty="0">
+                <a:latin typeface="Arial" panose="020B0604020202020204" pitchFamily="34" charset="0"/>
+                <a:cs typeface="Arial" panose="020B0604020202020204" pitchFamily="34" charset="0"/>
+              </a:rPr>
+              <a:t> </a:t>
+            </a:r>
+            <a:r>
+              <a:rPr lang="en-US" sz="1200" dirty="0" err="1">
+                <a:latin typeface="Arial" panose="020B0604020202020204" pitchFamily="34" charset="0"/>
+                <a:cs typeface="Arial" panose="020B0604020202020204" pitchFamily="34" charset="0"/>
+              </a:rPr>
+              <a:t>tiene</a:t>
+            </a:r>
+            <a:r>
+              <a:rPr lang="en-US" sz="1200" dirty="0">
+                <a:latin typeface="Arial" panose="020B0604020202020204" pitchFamily="34" charset="0"/>
+                <a:cs typeface="Arial" panose="020B0604020202020204" pitchFamily="34" charset="0"/>
+              </a:rPr>
+              <a:t> 28 </a:t>
+            </a:r>
+            <a:r>
+              <a:rPr lang="en-US" sz="1200" dirty="0" err="1">
+                <a:latin typeface="Arial" panose="020B0604020202020204" pitchFamily="34" charset="0"/>
+                <a:cs typeface="Arial" panose="020B0604020202020204" pitchFamily="34" charset="0"/>
+              </a:rPr>
+              <a:t>modos</a:t>
+            </a:r>
+            <a:r>
+              <a:rPr lang="en-US" sz="1200" dirty="0">
+                <a:latin typeface="Arial" panose="020B0604020202020204" pitchFamily="34" charset="0"/>
+                <a:cs typeface="Arial" panose="020B0604020202020204" pitchFamily="34" charset="0"/>
+              </a:rPr>
+              <a:t> </a:t>
+            </a:r>
+            <a:r>
+              <a:rPr lang="en-US" sz="1200" dirty="0" err="1">
+                <a:latin typeface="Arial" panose="020B0604020202020204" pitchFamily="34" charset="0"/>
+                <a:cs typeface="Arial" panose="020B0604020202020204" pitchFamily="34" charset="0"/>
+              </a:rPr>
+              <a:t>que</a:t>
+            </a:r>
+            <a:r>
+              <a:rPr lang="en-US" sz="1200" dirty="0">
+                <a:latin typeface="Arial" panose="020B0604020202020204" pitchFamily="34" charset="0"/>
+                <a:cs typeface="Arial" panose="020B0604020202020204" pitchFamily="34" charset="0"/>
+              </a:rPr>
+              <a:t> se </a:t>
+            </a:r>
+            <a:r>
+              <a:rPr lang="en-US" sz="1200" dirty="0" err="1">
+                <a:latin typeface="Arial" panose="020B0604020202020204" pitchFamily="34" charset="0"/>
+                <a:cs typeface="Arial" panose="020B0604020202020204" pitchFamily="34" charset="0"/>
+              </a:rPr>
+              <a:t>propagan</a:t>
+            </a:r>
+            <a:r>
+              <a:rPr lang="en-US" sz="1200" dirty="0">
+                <a:latin typeface="Arial" panose="020B0604020202020204" pitchFamily="34" charset="0"/>
+                <a:cs typeface="Arial" panose="020B0604020202020204" pitchFamily="34" charset="0"/>
+              </a:rPr>
+              <a:t>. </a:t>
+            </a:r>
+          </a:p>
+          <a:p>
+            <a:pPr algn="just"/>
+            <a:endParaRPr lang="en-US" sz="1200" dirty="0">
+              <a:latin typeface="Arial" panose="020B0604020202020204" pitchFamily="34" charset="0"/>
+              <a:cs typeface="Arial" panose="020B0604020202020204" pitchFamily="34" charset="0"/>
+            </a:endParaRPr>
+          </a:p>
+          <a:p>
+            <a:pPr algn="just"/>
+            <a:r>
+              <a:rPr lang="en-US" sz="1200" dirty="0">
+                <a:latin typeface="Arial" panose="020B0604020202020204" pitchFamily="34" charset="0"/>
+                <a:cs typeface="Arial" panose="020B0604020202020204" pitchFamily="34" charset="0"/>
+              </a:rPr>
+              <a:t>	</a:t>
+            </a:r>
+          </a:p>
+          <a:p>
+            <a:pPr algn="just"/>
+            <a:endParaRPr lang="en-US" sz="1200" dirty="0">
+              <a:latin typeface="Arial" panose="020B0604020202020204" pitchFamily="34" charset="0"/>
+              <a:cs typeface="Arial" panose="020B0604020202020204" pitchFamily="34" charset="0"/>
+            </a:endParaRPr>
+          </a:p>
+          <a:p>
+            <a:pPr algn="just"/>
+            <a:endParaRPr lang="en-US" sz="1200" dirty="0">
+              <a:latin typeface="Arial" panose="020B0604020202020204" pitchFamily="34" charset="0"/>
+              <a:cs typeface="Arial" panose="020B0604020202020204" pitchFamily="34" charset="0"/>
+            </a:endParaRPr>
+          </a:p>
+          <a:p>
+            <a:pPr algn="just"/>
+            <a:endParaRPr lang="en-US" sz="1200" dirty="0">
+              <a:latin typeface="Arial" panose="020B0604020202020204" pitchFamily="34" charset="0"/>
+              <a:cs typeface="Arial" panose="020B0604020202020204" pitchFamily="34" charset="0"/>
+            </a:endParaRPr>
+          </a:p>
+          <a:p>
+            <a:pPr algn="just"/>
+            <a:endParaRPr lang="en-US" sz="1200" dirty="0">
+              <a:latin typeface="Arial" panose="020B0604020202020204" pitchFamily="34" charset="0"/>
+              <a:cs typeface="Arial" panose="020B0604020202020204" pitchFamily="34" charset="0"/>
+            </a:endParaRPr>
+          </a:p>
+        </p:txBody>
+      </p:sp>
+      <p:pic>
+        <p:nvPicPr>
+          <p:cNvPr id="7" name="Imagen 6" descr="Texto&#10;&#10;El contenido generado por IA puede ser incorrecto.">
+            <a:extLst>
+              <a:ext uri="{FF2B5EF4-FFF2-40B4-BE49-F238E27FC236}">
+                <a16:creationId xmlns:a16="http://schemas.microsoft.com/office/drawing/2014/main" id="{C586736E-65CD-9FAD-18C0-AD8B6899C008}"/>
+              </a:ext>
+            </a:extLst>
+          </p:cNvPr>
+          <p:cNvPicPr>
+            <a:picLocks noChangeAspect="1"/>
+          </p:cNvPicPr>
+          <p:nvPr/>
+        </p:nvPicPr>
+        <p:blipFill>
+          <a:blip r:embed="rId5"/>
+          <a:stretch>
+            <a:fillRect/>
+          </a:stretch>
+        </p:blipFill>
+        <p:spPr>
+          <a:xfrm>
+            <a:off x="2733026" y="890475"/>
+            <a:ext cx="5996569" cy="3693887"/>
+          </a:xfrm>
+          <a:prstGeom prst="rect">
+            <a:avLst/>
+          </a:prstGeom>
+        </p:spPr>
+      </p:pic>
+      <p:sp>
+        <p:nvSpPr>
+          <p:cNvPr id="5" name="Rectángulo 4">
+            <a:extLst>
+              <a:ext uri="{FF2B5EF4-FFF2-40B4-BE49-F238E27FC236}">
+                <a16:creationId xmlns:a16="http://schemas.microsoft.com/office/drawing/2014/main" id="{AA13555D-B206-9A4A-2432-2E0AF05E3C82}"/>
+              </a:ext>
+            </a:extLst>
+          </p:cNvPr>
+          <p:cNvSpPr/>
+          <p:nvPr/>
+        </p:nvSpPr>
+        <p:spPr>
+          <a:xfrm>
+            <a:off x="5638800" y="3276600"/>
+            <a:ext cx="2133600" cy="228600"/>
+          </a:xfrm>
+          <a:prstGeom prst="rect">
+            <a:avLst/>
+          </a:prstGeom>
+          <a:noFill/>
+          <a:ln>
+            <a:solidFill>
+              <a:srgbClr val="FF0000"/>
+            </a:solidFill>
+          </a:ln>
+        </p:spPr>
+        <p:style>
+          <a:lnRef idx="2">
+            <a:schemeClr val="accent1">
+              <a:shade val="15000"/>
+            </a:schemeClr>
+          </a:lnRef>
+          <a:fillRef idx="1">
+            <a:schemeClr val="accent1"/>
+          </a:fillRef>
+          <a:effectRef idx="0">
+            <a:schemeClr val="accent1"/>
+          </a:effectRef>
+          <a:fontRef idx="minor">
+            <a:schemeClr val="lt1"/>
+          </a:fontRef>
+        </p:style>
+        <p:txBody>
+          <a:bodyPr rtlCol="0" anchor="ctr"/>
+          <a:lstStyle/>
+          <a:p>
+            <a:pPr algn="ctr"/>
+            <a:endParaRPr lang="es-ES"/>
+          </a:p>
+        </p:txBody>
+      </p:sp>
+    </p:spTree>
+    <p:extLst>
+      <p:ext uri="{BB962C8B-B14F-4D97-AF65-F5344CB8AC3E}">
+        <p14:creationId xmlns:p14="http://schemas.microsoft.com/office/powerpoint/2010/main" val="2182166031"/>
+      </p:ext>
+    </p:extLst>
+  </p:cSld>
+  <p:clrMapOvr>
+    <a:masterClrMapping/>
+  </p:clrMapOvr>
+</p:sld>
+</file>
+
+<file path=ppt/slides/slide13.xml><?xml version="1.0" encoding="utf-8"?>
+<p:sld xmlns:a="http://schemas.openxmlformats.org/drawingml/2006/main" xmlns:r="http://schemas.openxmlformats.org/officeDocument/2006/relationships" xmlns:p="http://schemas.openxmlformats.org/presentationml/2006/main">
+  <p:cSld>
+    <p:spTree>
+      <p:nvGrpSpPr>
+        <p:cNvPr id="1" name="">
+          <a:extLst>
+            <a:ext uri="{FF2B5EF4-FFF2-40B4-BE49-F238E27FC236}">
+              <a16:creationId xmlns:a16="http://schemas.microsoft.com/office/drawing/2014/main" id="{8B4DAF43-ABE2-BC78-562B-CD016382062D}"/>
+            </a:ext>
+          </a:extLst>
+        </p:cNvPr>
+        <p:cNvGrpSpPr/>
+        <p:nvPr/>
+      </p:nvGrpSpPr>
+      <p:grpSpPr>
+        <a:xfrm>
+          <a:off x="0" y="0"/>
+          <a:ext cx="0" cy="0"/>
+          <a:chOff x="0" y="0"/>
+          <a:chExt cx="0" cy="0"/>
+        </a:xfrm>
+      </p:grpSpPr>
+      <p:sp>
+        <p:nvSpPr>
+          <p:cNvPr id="16" name="object 16">
+            <a:extLst>
+              <a:ext uri="{FF2B5EF4-FFF2-40B4-BE49-F238E27FC236}">
+                <a16:creationId xmlns:a16="http://schemas.microsoft.com/office/drawing/2014/main" id="{E7C14D95-5B6A-9E67-E1BD-B6C350CBB58E}"/>
+              </a:ext>
+            </a:extLst>
+          </p:cNvPr>
+          <p:cNvSpPr txBox="1">
+            <a:spLocks noGrp="1"/>
+          </p:cNvSpPr>
+          <p:nvPr>
+            <p:ph type="title"/>
+          </p:nvPr>
+        </p:nvSpPr>
+        <p:spPr>
+          <a:xfrm>
+            <a:off x="685800" y="408883"/>
+            <a:ext cx="10994410" cy="397545"/>
+          </a:xfrm>
+          <a:prstGeom prst="rect">
+            <a:avLst/>
+          </a:prstGeom>
+        </p:spPr>
+        <p:txBody>
+          <a:bodyPr vert="horz" wrap="square" lIns="0" tIns="12700" rIns="0" bIns="0" rtlCol="0">
+            <a:spAutoFit/>
+          </a:bodyPr>
+          <a:lstStyle/>
+          <a:p>
+            <a:pPr marL="12700">
+              <a:lnSpc>
+                <a:spcPct val="100000"/>
+              </a:lnSpc>
+              <a:spcBef>
+                <a:spcPts val="100"/>
+              </a:spcBef>
+            </a:pPr>
+            <a:r>
+              <a:rPr lang="en-US" sz="2500" dirty="0"/>
+              <a:t>Learning outcome #2 – Multimode Interference (MMI) Coupler cross-section</a:t>
+            </a:r>
+            <a:endParaRPr lang="en-US" sz="2500" b="0" dirty="0">
+              <a:latin typeface="+mj-lt"/>
+              <a:cs typeface="Lucida Sans"/>
+            </a:endParaRPr>
+          </a:p>
+        </p:txBody>
+      </p:sp>
+      <p:pic>
+        <p:nvPicPr>
+          <p:cNvPr id="83" name="Gráfico 82">
+            <a:extLst>
+              <a:ext uri="{FF2B5EF4-FFF2-40B4-BE49-F238E27FC236}">
+                <a16:creationId xmlns:a16="http://schemas.microsoft.com/office/drawing/2014/main" id="{92AB7265-B7F7-D3D6-72A1-8A2E5DAE6277}"/>
+              </a:ext>
+            </a:extLst>
+          </p:cNvPr>
+          <p:cNvPicPr>
+            <a:picLocks noChangeAspect="1"/>
+          </p:cNvPicPr>
+          <p:nvPr/>
+        </p:nvPicPr>
+        <p:blipFill>
+          <a:blip r:embed="rId3">
+            <a:extLst>
+              <a:ext uri="{96DAC541-7B7A-43D3-8B79-37D633B846F1}">
+                <asvg:svgBlip xmlns:asvg="http://schemas.microsoft.com/office/drawing/2016/SVG/main" r:embed="rId4"/>
+              </a:ext>
+            </a:extLst>
+          </a:blip>
+          <a:stretch>
+            <a:fillRect/>
+          </a:stretch>
+        </p:blipFill>
+        <p:spPr>
+          <a:xfrm>
+            <a:off x="5045006" y="6356057"/>
+            <a:ext cx="6409575" cy="363174"/>
+          </a:xfrm>
+          <a:prstGeom prst="rect">
+            <a:avLst/>
+          </a:prstGeom>
+        </p:spPr>
+      </p:pic>
+      <p:sp>
+        <p:nvSpPr>
+          <p:cNvPr id="84" name="Marcador de número de diapositiva 83">
+            <a:extLst>
+              <a:ext uri="{FF2B5EF4-FFF2-40B4-BE49-F238E27FC236}">
+                <a16:creationId xmlns:a16="http://schemas.microsoft.com/office/drawing/2014/main" id="{82DC5A9A-9286-2BD5-0120-2455328E0446}"/>
+              </a:ext>
+            </a:extLst>
+          </p:cNvPr>
+          <p:cNvSpPr>
+            <a:spLocks noGrp="1"/>
+          </p:cNvSpPr>
+          <p:nvPr>
+            <p:ph type="sldNum" sz="quarter" idx="7"/>
+          </p:nvPr>
+        </p:nvSpPr>
+        <p:spPr/>
+        <p:txBody>
+          <a:bodyPr/>
+          <a:lstStyle/>
+          <a:p>
+            <a:fld id="{B6F15528-21DE-4FAA-801E-634DDDAF4B2B}" type="slidenum">
+              <a:rPr lang="es-ES" smtClean="0"/>
+              <a:t>13</a:t>
+            </a:fld>
+            <a:endParaRPr lang="es-ES"/>
+          </a:p>
+        </p:txBody>
+      </p:sp>
+      <p:sp>
+        <p:nvSpPr>
+          <p:cNvPr id="3" name="Marcador de pie de página 2">
+            <a:extLst>
+              <a:ext uri="{FF2B5EF4-FFF2-40B4-BE49-F238E27FC236}">
+                <a16:creationId xmlns:a16="http://schemas.microsoft.com/office/drawing/2014/main" id="{57FC0E2E-AF5D-C62F-3223-6156977A4BE0}"/>
+              </a:ext>
+            </a:extLst>
+          </p:cNvPr>
+          <p:cNvSpPr>
+            <a:spLocks noGrp="1"/>
+          </p:cNvSpPr>
+          <p:nvPr>
+            <p:ph type="ftr" sz="quarter" idx="5"/>
+          </p:nvPr>
+        </p:nvSpPr>
+        <p:spPr/>
+        <p:txBody>
+          <a:bodyPr/>
+          <a:lstStyle/>
+          <a:p>
+            <a:pPr marL="12700">
+              <a:spcBef>
+                <a:spcPts val="15"/>
+              </a:spcBef>
+            </a:pPr>
+            <a:r>
+              <a:rPr lang="es-ES" spc="-5"/>
+              <a:t>LAB 0.2. COUPLERS</a:t>
+            </a:r>
+            <a:endParaRPr lang="es-ES" spc="-5" dirty="0"/>
+          </a:p>
+        </p:txBody>
+      </p:sp>
+      <p:sp>
+        <p:nvSpPr>
+          <p:cNvPr id="4" name="Marcador de texto 2">
+            <a:extLst>
+              <a:ext uri="{FF2B5EF4-FFF2-40B4-BE49-F238E27FC236}">
+                <a16:creationId xmlns:a16="http://schemas.microsoft.com/office/drawing/2014/main" id="{E7D6679C-1F49-FA83-5F6C-B17D1C8DB944}"/>
+              </a:ext>
+            </a:extLst>
+          </p:cNvPr>
+          <p:cNvSpPr txBox="1">
+            <a:spLocks/>
+          </p:cNvSpPr>
+          <p:nvPr/>
+        </p:nvSpPr>
+        <p:spPr>
+          <a:xfrm>
+            <a:off x="608012" y="1295400"/>
+            <a:ext cx="11048999" cy="4958137"/>
+          </a:xfrm>
+          <a:prstGeom prst="rect">
+            <a:avLst/>
+          </a:prstGeom>
+        </p:spPr>
+        <p:txBody>
+          <a:bodyPr>
+            <a:normAutofit/>
+          </a:bodyPr>
+          <a:lstStyle>
+            <a:lvl1pPr marL="0">
+              <a:defRPr>
+                <a:latin typeface="+mn-lt"/>
+                <a:ea typeface="+mn-ea"/>
+                <a:cs typeface="+mn-cs"/>
+              </a:defRPr>
+            </a:lvl1pPr>
+            <a:lvl2pPr marL="457200">
+              <a:defRPr>
+                <a:latin typeface="+mn-lt"/>
+                <a:ea typeface="+mn-ea"/>
+                <a:cs typeface="+mn-cs"/>
+              </a:defRPr>
+            </a:lvl2pPr>
+            <a:lvl3pPr marL="914400">
+              <a:defRPr>
+                <a:latin typeface="+mn-lt"/>
+                <a:ea typeface="+mn-ea"/>
+                <a:cs typeface="+mn-cs"/>
+              </a:defRPr>
+            </a:lvl3pPr>
+            <a:lvl4pPr marL="1371600">
+              <a:defRPr>
+                <a:latin typeface="+mn-lt"/>
+                <a:ea typeface="+mn-ea"/>
+                <a:cs typeface="+mn-cs"/>
+              </a:defRPr>
+            </a:lvl4pPr>
+            <a:lvl5pPr marL="1828800">
+              <a:defRPr>
+                <a:latin typeface="+mn-lt"/>
+                <a:ea typeface="+mn-ea"/>
+                <a:cs typeface="+mn-cs"/>
+              </a:defRPr>
+            </a:lvl5pPr>
+            <a:lvl6pPr marL="2286000">
+              <a:defRPr>
+                <a:latin typeface="+mn-lt"/>
+                <a:ea typeface="+mn-ea"/>
+                <a:cs typeface="+mn-cs"/>
+              </a:defRPr>
+            </a:lvl6pPr>
+            <a:lvl7pPr marL="2743200">
+              <a:defRPr>
+                <a:latin typeface="+mn-lt"/>
+                <a:ea typeface="+mn-ea"/>
+                <a:cs typeface="+mn-cs"/>
+              </a:defRPr>
+            </a:lvl7pPr>
+            <a:lvl8pPr marL="3200400">
+              <a:defRPr>
+                <a:latin typeface="+mn-lt"/>
+                <a:ea typeface="+mn-ea"/>
+                <a:cs typeface="+mn-cs"/>
+              </a:defRPr>
+            </a:lvl8pPr>
+            <a:lvl9pPr marL="3657600">
+              <a:defRPr>
+                <a:latin typeface="+mn-lt"/>
+                <a:ea typeface="+mn-ea"/>
+                <a:cs typeface="+mn-cs"/>
+              </a:defRPr>
+            </a:lvl9pPr>
+          </a:lstStyle>
+          <a:p>
+            <a:pPr algn="just"/>
+            <a:endParaRPr lang="en-US" sz="2000" b="1" i="1" u="sng" dirty="0"/>
+          </a:p>
+          <a:p>
+            <a:pPr algn="just"/>
+            <a:endParaRPr lang="en-US" sz="2000" kern="0" dirty="0">
+              <a:solidFill>
+                <a:sysClr val="windowText" lastClr="000000"/>
+              </a:solidFill>
+            </a:endParaRPr>
+          </a:p>
+        </p:txBody>
+      </p:sp>
+      <p:sp>
+        <p:nvSpPr>
+          <p:cNvPr id="2" name="CuadroTexto 1">
+            <a:extLst>
+              <a:ext uri="{FF2B5EF4-FFF2-40B4-BE49-F238E27FC236}">
+                <a16:creationId xmlns:a16="http://schemas.microsoft.com/office/drawing/2014/main" id="{8A1E3F15-2560-F57E-4034-4AAAD3D0AFC7}"/>
+              </a:ext>
+            </a:extLst>
+          </p:cNvPr>
+          <p:cNvSpPr txBox="1"/>
+          <p:nvPr/>
+        </p:nvSpPr>
+        <p:spPr>
+          <a:xfrm>
+            <a:off x="608012" y="2719084"/>
+            <a:ext cx="11199971" cy="1384995"/>
+          </a:xfrm>
+          <a:prstGeom prst="rect">
+            <a:avLst/>
+          </a:prstGeom>
+          <a:solidFill>
+            <a:schemeClr val="bg1">
+              <a:lumMod val="95000"/>
+            </a:schemeClr>
+          </a:solidFill>
+          <a:ln w="28575">
+            <a:solidFill>
+              <a:srgbClr val="E0700D"/>
+            </a:solidFill>
+          </a:ln>
+        </p:spPr>
+        <p:txBody>
+          <a:bodyPr wrap="square" rtlCol="0">
+            <a:spAutoFit/>
+          </a:bodyPr>
+          <a:lstStyle/>
+          <a:p>
+            <a:pPr algn="just"/>
+            <a:r>
+              <a:rPr lang="en-US" sz="1200" dirty="0" err="1">
+                <a:latin typeface="Arial" panose="020B0604020202020204" pitchFamily="34" charset="0"/>
+                <a:cs typeface="Arial" panose="020B0604020202020204" pitchFamily="34" charset="0"/>
+              </a:rPr>
+              <a:t>Hemos</a:t>
+            </a:r>
+            <a:r>
+              <a:rPr lang="en-US" sz="1200" dirty="0">
+                <a:latin typeface="Arial" panose="020B0604020202020204" pitchFamily="34" charset="0"/>
+                <a:cs typeface="Arial" panose="020B0604020202020204" pitchFamily="34" charset="0"/>
+              </a:rPr>
+              <a:t> </a:t>
+            </a:r>
+            <a:r>
+              <a:rPr lang="en-US" sz="1200" dirty="0" err="1">
+                <a:latin typeface="Arial" panose="020B0604020202020204" pitchFamily="34" charset="0"/>
+                <a:cs typeface="Arial" panose="020B0604020202020204" pitchFamily="34" charset="0"/>
+              </a:rPr>
+              <a:t>calculado</a:t>
+            </a:r>
+            <a:r>
+              <a:rPr lang="en-US" sz="1200" dirty="0">
+                <a:latin typeface="Arial" panose="020B0604020202020204" pitchFamily="34" charset="0"/>
+                <a:cs typeface="Arial" panose="020B0604020202020204" pitchFamily="34" charset="0"/>
+              </a:rPr>
+              <a:t> la </a:t>
+            </a:r>
+            <a:r>
+              <a:rPr lang="en-US" sz="1200" dirty="0" err="1">
+                <a:latin typeface="Arial" panose="020B0604020202020204" pitchFamily="34" charset="0"/>
+                <a:cs typeface="Arial" panose="020B0604020202020204" pitchFamily="34" charset="0"/>
+              </a:rPr>
+              <a:t>distancia</a:t>
+            </a:r>
+            <a:r>
+              <a:rPr lang="en-US" sz="1200" dirty="0">
+                <a:latin typeface="Arial" panose="020B0604020202020204" pitchFamily="34" charset="0"/>
+                <a:cs typeface="Arial" panose="020B0604020202020204" pitchFamily="34" charset="0"/>
+              </a:rPr>
+              <a:t> de </a:t>
+            </a:r>
+            <a:r>
+              <a:rPr lang="en-US" sz="1200" dirty="0" err="1">
+                <a:latin typeface="Arial" panose="020B0604020202020204" pitchFamily="34" charset="0"/>
+                <a:cs typeface="Arial" panose="020B0604020202020204" pitchFamily="34" charset="0"/>
+              </a:rPr>
+              <a:t>autoimagen</a:t>
+            </a:r>
+            <a:r>
+              <a:rPr lang="en-US" sz="1200" dirty="0">
+                <a:latin typeface="Arial" panose="020B0604020202020204" pitchFamily="34" charset="0"/>
+                <a:cs typeface="Arial" panose="020B0604020202020204" pitchFamily="34" charset="0"/>
+              </a:rPr>
+              <a:t>, </a:t>
+            </a:r>
+            <a:r>
+              <a:rPr lang="en-US" sz="1200" dirty="0" err="1">
+                <a:latin typeface="Arial" panose="020B0604020202020204" pitchFamily="34" charset="0"/>
+                <a:cs typeface="Arial" panose="020B0604020202020204" pitchFamily="34" charset="0"/>
+              </a:rPr>
+              <a:t>que</a:t>
+            </a:r>
+            <a:r>
+              <a:rPr lang="en-US" sz="1200" dirty="0">
+                <a:latin typeface="Arial" panose="020B0604020202020204" pitchFamily="34" charset="0"/>
+                <a:cs typeface="Arial" panose="020B0604020202020204" pitchFamily="34" charset="0"/>
+              </a:rPr>
+              <a:t> es a la </a:t>
+            </a:r>
+            <a:r>
+              <a:rPr lang="en-US" sz="1200" dirty="0" err="1">
+                <a:latin typeface="Arial" panose="020B0604020202020204" pitchFamily="34" charset="0"/>
+                <a:cs typeface="Arial" panose="020B0604020202020204" pitchFamily="34" charset="0"/>
+              </a:rPr>
+              <a:t>cual</a:t>
+            </a:r>
+            <a:r>
+              <a:rPr lang="en-US" sz="1200" dirty="0">
+                <a:latin typeface="Arial" panose="020B0604020202020204" pitchFamily="34" charset="0"/>
+                <a:cs typeface="Arial" panose="020B0604020202020204" pitchFamily="34" charset="0"/>
+              </a:rPr>
+              <a:t> se </a:t>
+            </a:r>
+            <a:r>
+              <a:rPr lang="en-US" sz="1200" dirty="0" err="1">
+                <a:latin typeface="Arial" panose="020B0604020202020204" pitchFamily="34" charset="0"/>
+                <a:cs typeface="Arial" panose="020B0604020202020204" pitchFamily="34" charset="0"/>
+              </a:rPr>
+              <a:t>producirán</a:t>
+            </a:r>
+            <a:r>
+              <a:rPr lang="en-US" sz="1200" dirty="0">
+                <a:latin typeface="Arial" panose="020B0604020202020204" pitchFamily="34" charset="0"/>
+                <a:cs typeface="Arial" panose="020B0604020202020204" pitchFamily="34" charset="0"/>
+              </a:rPr>
+              <a:t> las replicas.  </a:t>
+            </a:r>
+          </a:p>
+          <a:p>
+            <a:pPr algn="just"/>
+            <a:endParaRPr lang="en-US" sz="1200" dirty="0">
+              <a:latin typeface="Arial" panose="020B0604020202020204" pitchFamily="34" charset="0"/>
+              <a:cs typeface="Arial" panose="020B0604020202020204" pitchFamily="34" charset="0"/>
+            </a:endParaRPr>
+          </a:p>
+          <a:p>
+            <a:pPr algn="just"/>
+            <a:r>
+              <a:rPr lang="en-US" sz="1200" dirty="0">
+                <a:latin typeface="Arial" panose="020B0604020202020204" pitchFamily="34" charset="0"/>
+                <a:cs typeface="Arial" panose="020B0604020202020204" pitchFamily="34" charset="0"/>
+              </a:rPr>
+              <a:t>	</a:t>
+            </a:r>
+          </a:p>
+          <a:p>
+            <a:pPr algn="just"/>
+            <a:endParaRPr lang="en-US" sz="1200" dirty="0">
+              <a:latin typeface="Arial" panose="020B0604020202020204" pitchFamily="34" charset="0"/>
+              <a:cs typeface="Arial" panose="020B0604020202020204" pitchFamily="34" charset="0"/>
+            </a:endParaRPr>
+          </a:p>
+          <a:p>
+            <a:pPr algn="just"/>
+            <a:endParaRPr lang="en-US" sz="1200" dirty="0">
+              <a:latin typeface="Arial" panose="020B0604020202020204" pitchFamily="34" charset="0"/>
+              <a:cs typeface="Arial" panose="020B0604020202020204" pitchFamily="34" charset="0"/>
+            </a:endParaRPr>
+          </a:p>
+          <a:p>
+            <a:pPr algn="just"/>
+            <a:endParaRPr lang="en-US" sz="1200" dirty="0">
+              <a:latin typeface="Arial" panose="020B0604020202020204" pitchFamily="34" charset="0"/>
+              <a:cs typeface="Arial" panose="020B0604020202020204" pitchFamily="34" charset="0"/>
+            </a:endParaRPr>
+          </a:p>
+          <a:p>
+            <a:pPr algn="just"/>
+            <a:endParaRPr lang="en-US" sz="1200" dirty="0">
+              <a:latin typeface="Arial" panose="020B0604020202020204" pitchFamily="34" charset="0"/>
+              <a:cs typeface="Arial" panose="020B0604020202020204" pitchFamily="34" charset="0"/>
+            </a:endParaRPr>
+          </a:p>
+        </p:txBody>
+      </p:sp>
+      <p:pic>
+        <p:nvPicPr>
+          <p:cNvPr id="8" name="Imagen 7">
+            <a:extLst>
+              <a:ext uri="{FF2B5EF4-FFF2-40B4-BE49-F238E27FC236}">
+                <a16:creationId xmlns:a16="http://schemas.microsoft.com/office/drawing/2014/main" id="{A44D2520-4F4C-BF8D-577A-AFB7A99B9C84}"/>
+              </a:ext>
+            </a:extLst>
+          </p:cNvPr>
+          <p:cNvPicPr>
+            <a:picLocks noChangeAspect="1"/>
+          </p:cNvPicPr>
+          <p:nvPr/>
+        </p:nvPicPr>
+        <p:blipFill>
+          <a:blip r:embed="rId5"/>
+          <a:stretch>
+            <a:fillRect/>
+          </a:stretch>
+        </p:blipFill>
+        <p:spPr>
+          <a:xfrm>
+            <a:off x="4419600" y="1611674"/>
+            <a:ext cx="2467319" cy="342948"/>
+          </a:xfrm>
+          <a:prstGeom prst="rect">
+            <a:avLst/>
+          </a:prstGeom>
+        </p:spPr>
+      </p:pic>
+    </p:spTree>
+    <p:extLst>
+      <p:ext uri="{BB962C8B-B14F-4D97-AF65-F5344CB8AC3E}">
+        <p14:creationId xmlns:p14="http://schemas.microsoft.com/office/powerpoint/2010/main" val="1565930768"/>
+      </p:ext>
+    </p:extLst>
+  </p:cSld>
+  <p:clrMapOvr>
+    <a:masterClrMapping/>
+  </p:clrMapOvr>
+</p:sld>
+</file>
+
+<file path=ppt/slides/slide14.xml><?xml version="1.0" encoding="utf-8"?>
+<p:sld xmlns:a="http://schemas.openxmlformats.org/drawingml/2006/main" xmlns:r="http://schemas.openxmlformats.org/officeDocument/2006/relationships" xmlns:p="http://schemas.openxmlformats.org/presentationml/2006/main">
+  <p:cSld>
+    <p:spTree>
+      <p:nvGrpSpPr>
         <p:cNvPr id="1" name=""/>
         <p:cNvGrpSpPr/>
         <p:nvPr/>
@@ -3717,7 +7095,7 @@
           <a:p>
             <a:fld id="{B6F15528-21DE-4FAA-801E-634DDDAF4B2B}" type="slidenum">
               <a:rPr lang="es-ES" smtClean="0"/>
-              <a:t>11</a:t>
+              <a:t>14</a:t>
             </a:fld>
             <a:endParaRPr lang="es-ES"/>
           </a:p>

</xml_diff>